<commit_message>
Add diagnostic task handout, answer key, and two deck slides
- 診断課題_配布資料.docx: participant handout with tasks A/B/C,
  source material, planted-error draft mail, and answer sheet
- 診断課題_講師用解答.docx: instructor answer key, 8-item scoring
  checklist, result bands, facilitation notes, scoring record table
- Deck: new slides for the diagnostic task and its scoring; agenda
  and section divider updated (now 15 slides)

Co-Authored-By: Claude Fable 5.1 <noreply@anthropic.com>
Claude-Session: https://claude.ai/code/session_01UQzmsGbHvNipHhmjBxKuyn
</commit_message>
<xml_diff>
--- a/claude-skills-lecture.pptx
+++ b/claude-skills-lecture.pptx
@@ -18,9 +18,11 @@
     <p:sldId id="266" r:id="rId12"/>
     <p:sldId id="267" r:id="rId13"/>
     <p:sldId id="268" r:id="rId14"/>
+    <p:sldId id="269" r:id="rId15"/>
+    <p:sldId id="270" r:id="rId16"/>
   </p:sldIdLst>
   <p:notesMasterIdLst>
-    <p:notesMasterId r:id="rId15"/>
+    <p:notesMasterId r:id="rId17"/>
   </p:notesMasterIdLst>
   <p:sldSz cx="9144000" cy="5143500"/>
   <p:notesSz cx="5143500" cy="9144000"/>
@@ -119,14 +121,14 @@
   <p:extLst>
     <p:ext uri="{521415D9-36F7-43E2-AB2F-B90AF26B5E84}">
       <p14:sectionLst xmlns:p14="http://schemas.microsoft.com/office/powerpoint/2010/main">
-        <p14:section name="はじめに" id="{13fcf11d-1747-3494-ba20-0b683cb669af}">
+        <p14:section name="はじめに" id="{450fa530-83c8-0831-3f57-cecba53c5495}">
           <p14:sldIdLst>
             <p14:sldId id="256"/>
             <p14:sldId id="257"/>
             <p14:sldId id="258"/>
           </p14:sldIdLst>
         </p14:section>
-        <p14:section name="6つのスキル" id="{d35e7b7f-30c1-0dad-a23a-22af9edeea3a}">
+        <p14:section name="6つのスキル" id="{b46ea51a-3964-3b0b-1a55-1ba51d5ad5aa}">
           <p14:sldIdLst>
             <p14:sldId id="259"/>
             <p14:sldId id="260"/>
@@ -134,18 +136,20 @@
             <p14:sldId id="262"/>
           </p14:sldIdLst>
         </p14:section>
-        <p14:section name="使われる人の特徴" id="{0a8a9ce2-c39b-cc2b-7d0e-a51b05dc3861}">
+        <p14:section name="使われる人の特徴" id="{712ea7c5-db3c-0fea-f800-907c93cd6d35}">
           <p14:sldIdLst>
             <p14:sldId id="263"/>
             <p14:sldId id="264"/>
             <p14:sldId id="265"/>
           </p14:sldIdLst>
         </p14:section>
-        <p14:section name="演習とまとめ" id="{94b9bb98-f7eb-4aad-7b92-2978fce28168}">
+        <p14:section name="演習とまとめ" id="{33f4aae5-d101-fb34-b783-f5e8cb45d6b6}">
           <p14:sldIdLst>
             <p14:sldId id="266"/>
             <p14:sldId id="267"/>
             <p14:sldId id="268"/>
+            <p14:sldId id="269"/>
+            <p14:sldId id="270"/>
           </p14:sldIdLst>
         </p14:section>
       </p14:sectionLst>
@@ -728,7 +732,7 @@
           <a:p>
             <a:r>
               <a:rPr lang="en-US" dirty="0"/>
-              <a:t>セクション3。演習は15分、まとめは5分を目安に。</a:t>
+              <a:t>セクション3。診断課題は30分、演習は15分、まとめは5分を目安に。診断課題の配布資料と講師用解答は別ファイル。</a:t>
             </a:r>
             <a:endParaRPr lang="en-US" dirty="0"/>
           </a:p>
@@ -816,7 +820,7 @@
           <a:p>
             <a:r>
               <a:rPr lang="en-US" dirty="0"/>
-              <a:t>演習のポイントは3番目のステップ。差が「見える」だけでなく「言語化できる」ことで、次の依頼から自分で再現できるようになる。</a:t>
+              <a:t>診断課題の配布資料と講師用解答は別ファイル。課題Aの誤りは「日付の違い」「元資料と逆の内容」「存在しない数字」の3種類。参加者には「正解を当てるテストではない」と伝え、普段のやり方で取り組んでもらう。種明かしは6つのスキルの後に行うと効果が高い。</a:t>
             </a:r>
             <a:endParaRPr lang="en-US" dirty="0"/>
           </a:p>
@@ -904,7 +908,7 @@
           <a:p>
             <a:r>
               <a:rPr lang="en-US" dirty="0"/>
-              <a:t>最後に講義冒頭の軸に戻って締める。3つの行動はどれも今日から実践できるものに絞っている。</a:t>
+              <a:t>採点は提出物3点を見れば10分程度。A3だけは本人に「Claudeに何を渡したか」を聞く。本人に返すときは×が集中した区分と、対応するスキルを一言添える。</a:t>
             </a:r>
             <a:endParaRPr lang="en-US" dirty="0"/>
           </a:p>
@@ -928,6 +932,182 @@
             <a:fld id="{F7021451-1387-4CA6-816F-3879F97B5CBC}" type="slidenum">
               <a:rPr lang="en-US"/>
               <a:t>13</a:t>
+            </a:fld>
+            <a:endParaRPr lang="en-US"/>
+          </a:p>
+        </p:txBody>
+      </p:sp>
+    </p:spTree>
+    <p:extLst>
+      <p:ext uri="{BB962C8B-B14F-4D97-AF65-F5344CB8AC3E}">
+        <p14:creationId xmlns:p14="http://schemas.microsoft.com/office/powerpoint/2010/main" val="1024086991"/>
+      </p:ext>
+    </p:extLst>
+  </p:cSld>
+  <p:clrMapOvr>
+    <a:masterClrMapping/>
+  </p:clrMapOvr>
+</p:notes>
+</file>
+
+<file path=ppt/notesSlides/notesSlide14.xml><?xml version="1.0" encoding="utf-8"?>
+<p:notes xmlns:a="http://schemas.openxmlformats.org/drawingml/2006/main" xmlns:r="http://schemas.openxmlformats.org/officeDocument/2006/relationships" xmlns:p="http://schemas.openxmlformats.org/presentationml/2006/main">
+  <p:cSld>
+    <p:spTree>
+      <p:nvGrpSpPr>
+        <p:cNvPr id="1" name=""/>
+        <p:cNvGrpSpPr/>
+        <p:nvPr/>
+      </p:nvGrpSpPr>
+      <p:grpSpPr>
+        <a:xfrm>
+          <a:off x="0" y="0"/>
+          <a:ext cx="0" cy="0"/>
+          <a:chOff x="0" y="0"/>
+          <a:chExt cx="0" cy="0"/>
+        </a:xfrm>
+      </p:grpSpPr>
+      <p:sp>
+        <p:nvSpPr>
+          <p:cNvPr id="2" name="Slide Image Placeholder 1"/>
+          <p:cNvSpPr>
+            <a:spLocks noGrp="1" noRot="1" noChangeAspect="1"/>
+          </p:cNvSpPr>
+          <p:nvPr>
+            <p:ph type="sldImg"/>
+          </p:nvPr>
+        </p:nvSpPr>
+        <p:spPr/>
+      </p:sp>
+      <p:sp>
+        <p:nvSpPr>
+          <p:cNvPr id="3" name="Notes Placeholder 2"/>
+          <p:cNvSpPr>
+            <a:spLocks noGrp="1"/>
+          </p:cNvSpPr>
+          <p:nvPr>
+            <p:ph type="body" idx="1"/>
+          </p:nvPr>
+        </p:nvSpPr>
+        <p:spPr/>
+        <p:txBody>
+          <a:bodyPr/>
+          <a:lstStyle/>
+          <a:p>
+            <a:r>
+              <a:rPr lang="en-US" dirty="0"/>
+              <a:t>演習のポイントは3番目のステップ。差が「見える」だけでなく「言語化できる」ことで、次の依頼から自分で再現できるようになる。</a:t>
+            </a:r>
+            <a:endParaRPr lang="en-US" dirty="0"/>
+          </a:p>
+        </p:txBody>
+      </p:sp>
+      <p:sp>
+        <p:nvSpPr>
+          <p:cNvPr id="4" name="Slide Number Placeholder 3"/>
+          <p:cNvSpPr>
+            <a:spLocks noGrp="1"/>
+          </p:cNvSpPr>
+          <p:nvPr>
+            <p:ph type="sldNum" sz="quarter" idx="10"/>
+          </p:nvPr>
+        </p:nvSpPr>
+        <p:spPr/>
+        <p:txBody>
+          <a:bodyPr/>
+          <a:lstStyle/>
+          <a:p>
+            <a:fld id="{F7021451-1387-4CA6-816F-3879F97B5CBC}" type="slidenum">
+              <a:rPr lang="en-US"/>
+              <a:t>14</a:t>
+            </a:fld>
+            <a:endParaRPr lang="en-US"/>
+          </a:p>
+        </p:txBody>
+      </p:sp>
+    </p:spTree>
+    <p:extLst>
+      <p:ext uri="{BB962C8B-B14F-4D97-AF65-F5344CB8AC3E}">
+        <p14:creationId xmlns:p14="http://schemas.microsoft.com/office/powerpoint/2010/main" val="1024086991"/>
+      </p:ext>
+    </p:extLst>
+  </p:cSld>
+  <p:clrMapOvr>
+    <a:masterClrMapping/>
+  </p:clrMapOvr>
+</p:notes>
+</file>
+
+<file path=ppt/notesSlides/notesSlide15.xml><?xml version="1.0" encoding="utf-8"?>
+<p:notes xmlns:a="http://schemas.openxmlformats.org/drawingml/2006/main" xmlns:r="http://schemas.openxmlformats.org/officeDocument/2006/relationships" xmlns:p="http://schemas.openxmlformats.org/presentationml/2006/main">
+  <p:cSld>
+    <p:spTree>
+      <p:nvGrpSpPr>
+        <p:cNvPr id="1" name=""/>
+        <p:cNvGrpSpPr/>
+        <p:nvPr/>
+      </p:nvGrpSpPr>
+      <p:grpSpPr>
+        <a:xfrm>
+          <a:off x="0" y="0"/>
+          <a:ext cx="0" cy="0"/>
+          <a:chOff x="0" y="0"/>
+          <a:chExt cx="0" cy="0"/>
+        </a:xfrm>
+      </p:grpSpPr>
+      <p:sp>
+        <p:nvSpPr>
+          <p:cNvPr id="2" name="Slide Image Placeholder 1"/>
+          <p:cNvSpPr>
+            <a:spLocks noGrp="1" noRot="1" noChangeAspect="1"/>
+          </p:cNvSpPr>
+          <p:nvPr>
+            <p:ph type="sldImg"/>
+          </p:nvPr>
+        </p:nvSpPr>
+        <p:spPr/>
+      </p:sp>
+      <p:sp>
+        <p:nvSpPr>
+          <p:cNvPr id="3" name="Notes Placeholder 2"/>
+          <p:cNvSpPr>
+            <a:spLocks noGrp="1"/>
+          </p:cNvSpPr>
+          <p:nvPr>
+            <p:ph type="body" idx="1"/>
+          </p:nvPr>
+        </p:nvSpPr>
+        <p:spPr/>
+        <p:txBody>
+          <a:bodyPr/>
+          <a:lstStyle/>
+          <a:p>
+            <a:r>
+              <a:rPr lang="en-US" dirty="0"/>
+              <a:t>最後に講義冒頭の軸に戻って締める。3つの行動はどれも今日から実践できるものに絞っている。</a:t>
+            </a:r>
+            <a:endParaRPr lang="en-US" dirty="0"/>
+          </a:p>
+        </p:txBody>
+      </p:sp>
+      <p:sp>
+        <p:nvSpPr>
+          <p:cNvPr id="4" name="Slide Number Placeholder 3"/>
+          <p:cNvSpPr>
+            <a:spLocks noGrp="1"/>
+          </p:cNvSpPr>
+          <p:nvPr>
+            <p:ph type="sldNum" sz="quarter" idx="10"/>
+          </p:nvPr>
+        </p:nvSpPr>
+        <p:spPr/>
+        <p:txBody>
+          <a:bodyPr/>
+          <a:lstStyle/>
+          <a:p>
+            <a:fld id="{F7021451-1387-4CA6-816F-3879F97B5CBC}" type="slidenum">
+              <a:rPr lang="en-US"/>
+              <a:t>15</a:t>
             </a:fld>
             <a:endParaRPr lang="en-US"/>
           </a:p>
@@ -3400,7 +3580,7 @@
                   <a:schemeClr val="bg1"/>
                 </a:solidFill>
               </a:rPr>
-              <a:t>演習とまとめ</a:t>
+              <a:t>診断課題・演習・まとめ</a:t>
             </a:r>
             <a:endParaRPr lang="en-US" sz="3400" dirty="0"/>
           </a:p>
@@ -3463,7 +3643,7 @@
                   <a:schemeClr val="tx2"/>
                 </a:solidFill>
               </a:rPr>
-              <a:t>演習：同じ課題を2通りの指示で試す</a:t>
+              <a:t>診断課題：30分で今の傾向を知る</a:t>
             </a:r>
             <a:endParaRPr lang="en-US" sz="2600" dirty="0"/>
           </a:p>
@@ -3471,18 +3651,18 @@
       </p:sp>
       <p:sp>
         <p:nvSpPr>
-          <p:cNvPr id="3" name="Step card 1"/>
+          <p:cNvPr id="3" name="Task card 1"/>
           <p:cNvSpPr/>
           <p:nvPr/>
         </p:nvSpPr>
         <p:spPr>
           <a:xfrm>
             <a:off x="457200" y="1188720"/>
-            <a:ext cx="2514600" cy="2194560"/>
+            <a:ext cx="2651760" cy="2514600"/>
           </a:xfrm>
           <a:prstGeom prst="roundRect">
             <a:avLst>
-              <a:gd name="adj" fmla="val 5000"/>
+              <a:gd name="adj" fmla="val 4364"/>
             </a:avLst>
           </a:prstGeom>
           <a:solidFill>
@@ -3498,14 +3678,14 @@
       </p:sp>
       <p:sp>
         <p:nvSpPr>
-          <p:cNvPr id="4" name="Step circle 1"/>
+          <p:cNvPr id="4" name="Task 1 circle"/>
           <p:cNvSpPr/>
           <p:nvPr/>
         </p:nvSpPr>
         <p:spPr>
           <a:xfrm>
-            <a:off x="685800" y="1417320"/>
-            <a:ext cx="594360" cy="594360"/>
+            <a:off x="640080" y="1371600"/>
+            <a:ext cx="502920" cy="502920"/>
           </a:xfrm>
           <a:prstGeom prst="ellipse">
             <a:avLst/>
@@ -3521,117 +3701,9 @@
           </a:ln>
         </p:spPr>
       </p:sp>
-      <p:sp>
-        <p:nvSpPr>
-          <p:cNvPr id="5" name="Step num 1"/>
-          <p:cNvSpPr txBox="1"/>
-          <p:nvPr/>
-        </p:nvSpPr>
-        <p:spPr>
-          <a:xfrm>
-            <a:off x="685800" y="1417320"/>
-            <a:ext cx="594360" cy="594360"/>
-          </a:xfrm>
-          <a:prstGeom prst="rect">
-            <a:avLst/>
-          </a:prstGeom>
-          <a:noFill/>
-          <a:ln/>
-        </p:spPr>
-        <p:txBody>
-          <a:bodyPr wrap="square" lIns="0" tIns="0" rIns="0" bIns="0" rtlCol="0" anchor="ctr"/>
-          <a:lstStyle/>
-          <a:p>
-            <a:pPr algn="ctr" indent="0" marL="0">
-              <a:buNone/>
-            </a:pPr>
-            <a:r>
-              <a:rPr lang="en-US" sz="2200" b="1" dirty="0">
-                <a:solidFill>
-                  <a:schemeClr val="bg1"/>
-                </a:solidFill>
-              </a:rPr>
-              <a:t>1</a:t>
-            </a:r>
-            <a:endParaRPr lang="en-US" sz="2200" dirty="0"/>
-          </a:p>
-        </p:txBody>
-      </p:sp>
-      <p:sp>
-        <p:nvSpPr>
-          <p:cNvPr id="6" name="Step head 1"/>
-          <p:cNvSpPr txBox="1"/>
-          <p:nvPr/>
-        </p:nvSpPr>
-        <p:spPr>
-          <a:xfrm>
-            <a:off x="685800" y="2148840"/>
-            <a:ext cx="2057400" cy="548640"/>
-          </a:xfrm>
-          <a:prstGeom prst="rect">
-            <a:avLst/>
-          </a:prstGeom>
-          <a:noFill/>
-          <a:ln/>
-        </p:spPr>
-        <p:txBody>
-          <a:bodyPr wrap="square" lIns="0" tIns="0" rIns="0" bIns="0" rtlCol="0" anchor="t"/>
-          <a:lstStyle/>
-          <a:p>
-            <a:pPr indent="0" marL="0">
-              <a:buNone/>
-            </a:pPr>
-            <a:r>
-              <a:rPr lang="en-US" sz="1400" b="1" dirty="0">
-                <a:solidFill>
-                  <a:schemeClr val="tx2"/>
-                </a:solidFill>
-              </a:rPr>
-              <a:t>一行で頼む</a:t>
-            </a:r>
-            <a:endParaRPr lang="en-US" sz="1400" dirty="0"/>
-          </a:p>
-        </p:txBody>
-      </p:sp>
-      <p:sp>
-        <p:nvSpPr>
-          <p:cNvPr id="7" name="Step desc 1"/>
-          <p:cNvSpPr txBox="1"/>
-          <p:nvPr/>
-        </p:nvSpPr>
-        <p:spPr>
-          <a:xfrm>
-            <a:off x="685800" y="2743200"/>
-            <a:ext cx="2057400" cy="594360"/>
-          </a:xfrm>
-          <a:prstGeom prst="rect">
-            <a:avLst/>
-          </a:prstGeom>
-          <a:noFill/>
-          <a:ln/>
-        </p:spPr>
-        <p:txBody>
-          <a:bodyPr wrap="square" lIns="0" tIns="0" rIns="0" bIns="0" rtlCol="0" anchor="t"/>
-          <a:lstStyle/>
-          <a:p>
-            <a:pPr indent="0" marL="0">
-              <a:buNone/>
-            </a:pPr>
-            <a:r>
-              <a:rPr lang="en-US" sz="1150" dirty="0">
-                <a:solidFill>
-                  <a:schemeClr val="tx1"/>
-                </a:solidFill>
-              </a:rPr>
-              <a:t>まず「いい感じに」のような短い指示で出力を得る</a:t>
-            </a:r>
-            <a:endParaRPr lang="en-US" sz="1150" dirty="0"/>
-          </a:p>
-        </p:txBody>
-      </p:sp>
       <p:pic>
         <p:nvPicPr>
-          <p:cNvPr id="8" name="Step arrow 1" descr="preencoded.png">    </p:cNvPr>
+          <p:cNvPr id="5" name="Task 1 icon" descr="preencoded.png">    </p:cNvPr>
           <p:cNvPicPr>
             <a:picLocks noChangeAspect="1"/>
           </p:cNvPicPr>
@@ -3645,8 +3717,8 @@
         </p:blipFill>
         <p:spPr>
           <a:xfrm>
-            <a:off x="3017520" y="2057400"/>
-            <a:ext cx="256032" cy="256032"/>
+            <a:off x="770839" y="1502359"/>
+            <a:ext cx="241402" cy="241402"/>
           </a:xfrm>
           <a:prstGeom prst="rect">
             <a:avLst/>
@@ -3655,18 +3727,137 @@
       </p:pic>
       <p:sp>
         <p:nvSpPr>
-          <p:cNvPr id="9" name="Step card 2"/>
+          <p:cNvPr id="6" name="Task head 1"/>
+          <p:cNvSpPr txBox="1"/>
+          <p:nvPr/>
+        </p:nvSpPr>
+        <p:spPr>
+          <a:xfrm>
+            <a:off x="1234440" y="1371600"/>
+            <a:ext cx="1737360" cy="502920"/>
+          </a:xfrm>
+          <a:prstGeom prst="rect">
+            <a:avLst/>
+          </a:prstGeom>
+          <a:noFill/>
+          <a:ln/>
+        </p:spPr>
+        <p:txBody>
+          <a:bodyPr wrap="square" lIns="0" tIns="0" rIns="0" bIns="0" rtlCol="0" anchor="ctr"/>
+          <a:lstStyle/>
+          <a:p>
+            <a:pPr indent="0" marL="0">
+              <a:buNone/>
+            </a:pPr>
+            <a:r>
+              <a:rPr lang="en-US" sz="1300" b="1" dirty="0">
+                <a:solidFill>
+                  <a:schemeClr val="tx2"/>
+                </a:solidFill>
+              </a:rPr>
+              <a:t>課題A　検証</a:t>
+            </a:r>
+            <a:endParaRPr lang="en-US" sz="1300" dirty="0"/>
+          </a:p>
+        </p:txBody>
+      </p:sp>
+      <p:sp>
+        <p:nvSpPr>
+          <p:cNvPr id="7" name="Task what 1"/>
+          <p:cNvSpPr txBox="1"/>
+          <p:nvPr/>
+        </p:nvSpPr>
+        <p:spPr>
+          <a:xfrm>
+            <a:off x="640080" y="2011680"/>
+            <a:ext cx="2286000" cy="731520"/>
+          </a:xfrm>
+          <a:prstGeom prst="rect">
+            <a:avLst/>
+          </a:prstGeom>
+          <a:noFill/>
+          <a:ln/>
+        </p:spPr>
+        <p:txBody>
+          <a:bodyPr wrap="square" lIns="0" tIns="0" rIns="0" bIns="0" rtlCol="0" anchor="t"/>
+          <a:lstStyle/>
+          <a:p>
+            <a:pPr indent="0" marL="0">
+              <a:buNone/>
+            </a:pPr>
+            <a:r>
+              <a:rPr lang="en-US" sz="1150" dirty="0">
+                <a:solidFill>
+                  <a:schemeClr val="tx1"/>
+                </a:solidFill>
+              </a:rPr>
+              <a:t>Claudeが書いた下書きメールを、元資料をもとに送れる状態に仕上げる</a:t>
+            </a:r>
+            <a:endParaRPr lang="en-US" sz="1150" dirty="0"/>
+          </a:p>
+        </p:txBody>
+      </p:sp>
+      <p:sp>
+        <p:nvSpPr>
+          <p:cNvPr id="8" name="Task obs 1"/>
+          <p:cNvSpPr txBox="1"/>
+          <p:nvPr/>
+        </p:nvSpPr>
+        <p:spPr>
+          <a:xfrm>
+            <a:off x="640080" y="2788920"/>
+            <a:ext cx="2286000" cy="822960"/>
+          </a:xfrm>
+          <a:prstGeom prst="rect">
+            <a:avLst/>
+          </a:prstGeom>
+          <a:noFill/>
+          <a:ln/>
+        </p:spPr>
+        <p:txBody>
+          <a:bodyPr wrap="square" lIns="0" tIns="0" rIns="0" bIns="0" rtlCol="0" anchor="t"/>
+          <a:lstStyle/>
+          <a:p>
+            <a:pPr indent="0" marL="0">
+              <a:buNone/>
+            </a:pPr>
+            <a:r>
+              <a:rPr lang="en-US" sz="1100" b="1" dirty="0">
+                <a:solidFill>
+                  <a:schemeClr val="accent1"/>
+                </a:solidFill>
+              </a:rPr>
+              <a:t>見る行動　</a:t>
+            </a:r>
+            <a:pPr indent="0" marL="0">
+              <a:buNone/>
+            </a:pPr>
+            <a:r>
+              <a:rPr lang="en-US" sz="1100" dirty="0">
+                <a:solidFill>
+                  <a:schemeClr val="tx1"/>
+                </a:solidFill>
+              </a:rPr>
+              <a:t>下書きに仕込んだ3つの誤りに気づくか。元資料と照合するか</a:t>
+            </a:r>
+            <a:endParaRPr lang="en-US" sz="1100" dirty="0"/>
+          </a:p>
+        </p:txBody>
+      </p:sp>
+      <p:sp>
+        <p:nvSpPr>
+          <p:cNvPr id="9" name="Task card 2"/>
           <p:cNvSpPr/>
           <p:nvPr/>
         </p:nvSpPr>
         <p:spPr>
           <a:xfrm>
-            <a:off x="3314700" y="1188720"/>
-            <a:ext cx="2514600" cy="2194560"/>
+            <a:off x="3246120" y="1188720"/>
+            <a:ext cx="2651760" cy="2514600"/>
           </a:xfrm>
           <a:prstGeom prst="roundRect">
             <a:avLst>
-              <a:gd name="adj" fmla="val 5000"/>
+              <a:gd name="adj" fmla="val 4364"/>
             </a:avLst>
           </a:prstGeom>
           <a:solidFill>
@@ -3682,14 +3873,14 @@
       </p:sp>
       <p:sp>
         <p:nvSpPr>
-          <p:cNvPr id="10" name="Step circle 2"/>
+          <p:cNvPr id="10" name="Task 2 circle"/>
           <p:cNvSpPr/>
           <p:nvPr/>
         </p:nvSpPr>
         <p:spPr>
           <a:xfrm>
-            <a:off x="3543300" y="1417320"/>
-            <a:ext cx="594360" cy="594360"/>
+            <a:off x="3429000" y="1371600"/>
+            <a:ext cx="502920" cy="502920"/>
           </a:xfrm>
           <a:prstGeom prst="ellipse">
             <a:avLst/>
@@ -3705,117 +3896,9 @@
           </a:ln>
         </p:spPr>
       </p:sp>
-      <p:sp>
-        <p:nvSpPr>
-          <p:cNvPr id="11" name="Step num 2"/>
-          <p:cNvSpPr txBox="1"/>
-          <p:nvPr/>
-        </p:nvSpPr>
-        <p:spPr>
-          <a:xfrm>
-            <a:off x="3543300" y="1417320"/>
-            <a:ext cx="594360" cy="594360"/>
-          </a:xfrm>
-          <a:prstGeom prst="rect">
-            <a:avLst/>
-          </a:prstGeom>
-          <a:noFill/>
-          <a:ln/>
-        </p:spPr>
-        <p:txBody>
-          <a:bodyPr wrap="square" lIns="0" tIns="0" rIns="0" bIns="0" rtlCol="0" anchor="ctr"/>
-          <a:lstStyle/>
-          <a:p>
-            <a:pPr algn="ctr" indent="0" marL="0">
-              <a:buNone/>
-            </a:pPr>
-            <a:r>
-              <a:rPr lang="en-US" sz="2200" b="1" dirty="0">
-                <a:solidFill>
-                  <a:schemeClr val="bg1"/>
-                </a:solidFill>
-              </a:rPr>
-              <a:t>2</a:t>
-            </a:r>
-            <a:endParaRPr lang="en-US" sz="2200" dirty="0"/>
-          </a:p>
-        </p:txBody>
-      </p:sp>
-      <p:sp>
-        <p:nvSpPr>
-          <p:cNvPr id="12" name="Step head 2"/>
-          <p:cNvSpPr txBox="1"/>
-          <p:nvPr/>
-        </p:nvSpPr>
-        <p:spPr>
-          <a:xfrm>
-            <a:off x="3543300" y="2148840"/>
-            <a:ext cx="2057400" cy="548640"/>
-          </a:xfrm>
-          <a:prstGeom prst="rect">
-            <a:avLst/>
-          </a:prstGeom>
-          <a:noFill/>
-          <a:ln/>
-        </p:spPr>
-        <p:txBody>
-          <a:bodyPr wrap="square" lIns="0" tIns="0" rIns="0" bIns="0" rtlCol="0" anchor="t"/>
-          <a:lstStyle/>
-          <a:p>
-            <a:pPr indent="0" marL="0">
-              <a:buNone/>
-            </a:pPr>
-            <a:r>
-              <a:rPr lang="en-US" sz="1400" b="1" dirty="0">
-                <a:solidFill>
-                  <a:schemeClr val="tx2"/>
-                </a:solidFill>
-              </a:rPr>
-              <a:t>目的・文脈・制約を添えて頼む</a:t>
-            </a:r>
-            <a:endParaRPr lang="en-US" sz="1400" dirty="0"/>
-          </a:p>
-        </p:txBody>
-      </p:sp>
-      <p:sp>
-        <p:nvSpPr>
-          <p:cNvPr id="13" name="Step desc 2"/>
-          <p:cNvSpPr txBox="1"/>
-          <p:nvPr/>
-        </p:nvSpPr>
-        <p:spPr>
-          <a:xfrm>
-            <a:off x="3543300" y="2743200"/>
-            <a:ext cx="2057400" cy="594360"/>
-          </a:xfrm>
-          <a:prstGeom prst="rect">
-            <a:avLst/>
-          </a:prstGeom>
-          <a:noFill/>
-          <a:ln/>
-        </p:spPr>
-        <p:txBody>
-          <a:bodyPr wrap="square" lIns="0" tIns="0" rIns="0" bIns="0" rtlCol="0" anchor="t"/>
-          <a:lstStyle/>
-          <a:p>
-            <a:pPr indent="0" marL="0">
-              <a:buNone/>
-            </a:pPr>
-            <a:r>
-              <a:rPr lang="en-US" sz="1150" dirty="0">
-                <a:solidFill>
-                  <a:schemeClr val="tx1"/>
-                </a:solidFill>
-              </a:rPr>
-              <a:t>誰向けか、何に使うか、長さや形式の条件を書いて同じ課題を頼む</a:t>
-            </a:r>
-            <a:endParaRPr lang="en-US" sz="1150" dirty="0"/>
-          </a:p>
-        </p:txBody>
-      </p:sp>
       <p:pic>
         <p:nvPicPr>
-          <p:cNvPr id="14" name="Step arrow 2" descr="preencoded.png">    </p:cNvPr>
+          <p:cNvPr id="11" name="Task 2 icon" descr="preencoded.png">    </p:cNvPr>
           <p:cNvPicPr>
             <a:picLocks noChangeAspect="1"/>
           </p:cNvPicPr>
@@ -3829,8 +3912,8 @@
         </p:blipFill>
         <p:spPr>
           <a:xfrm>
-            <a:off x="5875020" y="2057400"/>
-            <a:ext cx="256032" cy="256032"/>
+            <a:off x="3559759" y="1502359"/>
+            <a:ext cx="241402" cy="241402"/>
           </a:xfrm>
           <a:prstGeom prst="rect">
             <a:avLst/>
@@ -3839,18 +3922,137 @@
       </p:pic>
       <p:sp>
         <p:nvSpPr>
-          <p:cNvPr id="15" name="Step card 3"/>
+          <p:cNvPr id="12" name="Task head 2"/>
+          <p:cNvSpPr txBox="1"/>
+          <p:nvPr/>
+        </p:nvSpPr>
+        <p:spPr>
+          <a:xfrm>
+            <a:off x="4023360" y="1371600"/>
+            <a:ext cx="1737360" cy="502920"/>
+          </a:xfrm>
+          <a:prstGeom prst="rect">
+            <a:avLst/>
+          </a:prstGeom>
+          <a:noFill/>
+          <a:ln/>
+        </p:spPr>
+        <p:txBody>
+          <a:bodyPr wrap="square" lIns="0" tIns="0" rIns="0" bIns="0" rtlCol="0" anchor="ctr"/>
+          <a:lstStyle/>
+          <a:p>
+            <a:pPr indent="0" marL="0">
+              <a:buNone/>
+            </a:pPr>
+            <a:r>
+              <a:rPr lang="en-US" sz="1300" b="1" dirty="0">
+                <a:solidFill>
+                  <a:schemeClr val="tx2"/>
+                </a:solidFill>
+              </a:rPr>
+              <a:t>課題B　指示</a:t>
+            </a:r>
+            <a:endParaRPr lang="en-US" sz="1300" dirty="0"/>
+          </a:p>
+        </p:txBody>
+      </p:sp>
+      <p:sp>
+        <p:nvSpPr>
+          <p:cNvPr id="13" name="Task what 2"/>
+          <p:cNvSpPr txBox="1"/>
+          <p:nvPr/>
+        </p:nvSpPr>
+        <p:spPr>
+          <a:xfrm>
+            <a:off x="3429000" y="2011680"/>
+            <a:ext cx="2286000" cy="731520"/>
+          </a:xfrm>
+          <a:prstGeom prst="rect">
+            <a:avLst/>
+          </a:prstGeom>
+          <a:noFill/>
+          <a:ln/>
+        </p:spPr>
+        <p:txBody>
+          <a:bodyPr wrap="square" lIns="0" tIns="0" rIns="0" bIns="0" rtlCol="0" anchor="t"/>
+          <a:lstStyle/>
+          <a:p>
+            <a:pPr indent="0" marL="0">
+              <a:buNone/>
+            </a:pPr>
+            <a:r>
+              <a:rPr lang="en-US" sz="1150" dirty="0">
+                <a:solidFill>
+                  <a:schemeClr val="tx1"/>
+                </a:solidFill>
+              </a:rPr>
+              <a:t>新人向け説明資料を作るための、Claudeへの最初の依頼文を書く</a:t>
+            </a:r>
+            <a:endParaRPr lang="en-US" sz="1150" dirty="0"/>
+          </a:p>
+        </p:txBody>
+      </p:sp>
+      <p:sp>
+        <p:nvSpPr>
+          <p:cNvPr id="14" name="Task obs 2"/>
+          <p:cNvSpPr txBox="1"/>
+          <p:nvPr/>
+        </p:nvSpPr>
+        <p:spPr>
+          <a:xfrm>
+            <a:off x="3429000" y="2788920"/>
+            <a:ext cx="2286000" cy="822960"/>
+          </a:xfrm>
+          <a:prstGeom prst="rect">
+            <a:avLst/>
+          </a:prstGeom>
+          <a:noFill/>
+          <a:ln/>
+        </p:spPr>
+        <p:txBody>
+          <a:bodyPr wrap="square" lIns="0" tIns="0" rIns="0" bIns="0" rtlCol="0" anchor="t"/>
+          <a:lstStyle/>
+          <a:p>
+            <a:pPr indent="0" marL="0">
+              <a:buNone/>
+            </a:pPr>
+            <a:r>
+              <a:rPr lang="en-US" sz="1100" b="1" dirty="0">
+                <a:solidFill>
+                  <a:schemeClr val="accent1"/>
+                </a:solidFill>
+              </a:rPr>
+              <a:t>見る行動　</a:t>
+            </a:r>
+            <a:pPr indent="0" marL="0">
+              <a:buNone/>
+            </a:pPr>
+            <a:r>
+              <a:rPr lang="en-US" sz="1100" dirty="0">
+                <a:solidFill>
+                  <a:schemeClr val="tx1"/>
+                </a:solidFill>
+              </a:rPr>
+              <a:t>依頼文に目的・文脈・制約が入っているか</a:t>
+            </a:r>
+            <a:endParaRPr lang="en-US" sz="1100" dirty="0"/>
+          </a:p>
+        </p:txBody>
+      </p:sp>
+      <p:sp>
+        <p:nvSpPr>
+          <p:cNvPr id="15" name="Task card 3"/>
           <p:cNvSpPr/>
           <p:nvPr/>
         </p:nvSpPr>
         <p:spPr>
           <a:xfrm>
-            <a:off x="6172200" y="1188720"/>
-            <a:ext cx="2514600" cy="2194560"/>
+            <a:off x="6035040" y="1188720"/>
+            <a:ext cx="2651760" cy="2514600"/>
           </a:xfrm>
           <a:prstGeom prst="roundRect">
             <a:avLst>
-              <a:gd name="adj" fmla="val 5000"/>
+              <a:gd name="adj" fmla="val 4364"/>
             </a:avLst>
           </a:prstGeom>
           <a:solidFill>
@@ -3866,14 +4068,14 @@
       </p:sp>
       <p:sp>
         <p:nvSpPr>
-          <p:cNvPr id="16" name="Step circle 3"/>
+          <p:cNvPr id="16" name="Task 3 circle"/>
           <p:cNvSpPr/>
           <p:nvPr/>
         </p:nvSpPr>
         <p:spPr>
           <a:xfrm>
-            <a:off x="6400800" y="1417320"/>
-            <a:ext cx="594360" cy="594360"/>
+            <a:off x="6217920" y="1371600"/>
+            <a:ext cx="502920" cy="502920"/>
           </a:xfrm>
           <a:prstGeom prst="ellipse">
             <a:avLst/>
@@ -3889,16 +4091,40 @@
           </a:ln>
         </p:spPr>
       </p:sp>
-      <p:sp>
-        <p:nvSpPr>
-          <p:cNvPr id="17" name="Step num 3"/>
+      <p:pic>
+        <p:nvPicPr>
+          <p:cNvPr id="17" name="Task 3 icon" descr="preencoded.png">    </p:cNvPr>
+          <p:cNvPicPr>
+            <a:picLocks noChangeAspect="1"/>
+          </p:cNvPicPr>
+          <p:nvPr/>
+        </p:nvPicPr>
+        <p:blipFill>
+          <a:blip r:embed="rId3"/>
+          <a:stretch>
+            <a:fillRect/>
+          </a:stretch>
+        </p:blipFill>
+        <p:spPr>
+          <a:xfrm>
+            <a:off x="6348679" y="1502359"/>
+            <a:ext cx="241402" cy="241402"/>
+          </a:xfrm>
+          <a:prstGeom prst="rect">
+            <a:avLst/>
+          </a:prstGeom>
+        </p:spPr>
+      </p:pic>
+      <p:sp>
+        <p:nvSpPr>
+          <p:cNvPr id="18" name="Task head 3"/>
           <p:cNvSpPr txBox="1"/>
           <p:nvPr/>
         </p:nvSpPr>
         <p:spPr>
           <a:xfrm>
-            <a:off x="6400800" y="1417320"/>
-            <a:ext cx="594360" cy="594360"/>
+            <a:off x="6812280" y="1371600"/>
+            <a:ext cx="1737360" cy="502920"/>
           </a:xfrm>
           <a:prstGeom prst="rect">
             <a:avLst/>
@@ -3910,31 +4136,31 @@
           <a:bodyPr wrap="square" lIns="0" tIns="0" rIns="0" bIns="0" rtlCol="0" anchor="ctr"/>
           <a:lstStyle/>
           <a:p>
-            <a:pPr algn="ctr" indent="0" marL="0">
-              <a:buNone/>
-            </a:pPr>
-            <a:r>
-              <a:rPr lang="en-US" sz="2200" b="1" dirty="0">
-                <a:solidFill>
-                  <a:schemeClr val="bg1"/>
-                </a:solidFill>
-              </a:rPr>
-              <a:t>3</a:t>
-            </a:r>
-            <a:endParaRPr lang="en-US" sz="2200" dirty="0"/>
-          </a:p>
-        </p:txBody>
-      </p:sp>
-      <p:sp>
-        <p:nvSpPr>
-          <p:cNvPr id="18" name="Step head 3"/>
+            <a:pPr indent="0" marL="0">
+              <a:buNone/>
+            </a:pPr>
+            <a:r>
+              <a:rPr lang="en-US" sz="1300" b="1" dirty="0">
+                <a:solidFill>
+                  <a:schemeClr val="tx2"/>
+                </a:solidFill>
+              </a:rPr>
+              <a:t>課題C　判断</a:t>
+            </a:r>
+            <a:endParaRPr lang="en-US" sz="1300" dirty="0"/>
+          </a:p>
+        </p:txBody>
+      </p:sp>
+      <p:sp>
+        <p:nvSpPr>
+          <p:cNvPr id="19" name="Task what 3"/>
           <p:cNvSpPr txBox="1"/>
           <p:nvPr/>
         </p:nvSpPr>
         <p:spPr>
           <a:xfrm>
-            <a:off x="6400800" y="2148840"/>
-            <a:ext cx="2057400" cy="548640"/>
+            <a:off x="6217920" y="2011680"/>
+            <a:ext cx="2286000" cy="731520"/>
           </a:xfrm>
           <a:prstGeom prst="rect">
             <a:avLst/>
@@ -3950,27 +4176,27 @@
               <a:buNone/>
             </a:pPr>
             <a:r>
-              <a:rPr lang="en-US" sz="1400" b="1" dirty="0">
-                <a:solidFill>
-                  <a:schemeClr val="tx2"/>
-                </a:solidFill>
-              </a:rPr>
-              <a:t>並べて比べ、違いを言葉にする</a:t>
-            </a:r>
-            <a:endParaRPr lang="en-US" sz="1400" dirty="0"/>
-          </a:p>
-        </p:txBody>
-      </p:sp>
-      <p:sp>
-        <p:nvSpPr>
-          <p:cNvPr id="19" name="Step desc 3"/>
+              <a:rPr lang="en-US" sz="1150" dirty="0">
+                <a:solidFill>
+                  <a:schemeClr val="tx1"/>
+                </a:solidFill>
+              </a:rPr>
+              <a:t>仕上げたメールの送り先をClaudeに相談し、最終判断を書く</a:t>
+            </a:r>
+            <a:endParaRPr lang="en-US" sz="1150" dirty="0"/>
+          </a:p>
+        </p:txBody>
+      </p:sp>
+      <p:sp>
+        <p:nvSpPr>
+          <p:cNvPr id="20" name="Task obs 3"/>
           <p:cNvSpPr txBox="1"/>
           <p:nvPr/>
         </p:nvSpPr>
         <p:spPr>
           <a:xfrm>
-            <a:off x="6400800" y="2743200"/>
-            <a:ext cx="2057400" cy="594360"/>
+            <a:off x="6217920" y="2788920"/>
+            <a:ext cx="2286000" cy="822960"/>
           </a:xfrm>
           <a:prstGeom prst="rect">
             <a:avLst/>
@@ -3986,31 +4212,42 @@
               <a:buNone/>
             </a:pPr>
             <a:r>
-              <a:rPr lang="en-US" sz="1150" dirty="0">
+              <a:rPr lang="en-US" sz="1100" b="1" dirty="0">
+                <a:solidFill>
+                  <a:schemeClr val="accent1"/>
+                </a:solidFill>
+              </a:rPr>
+              <a:t>見る行動　</a:t>
+            </a:r>
+            <a:pPr indent="0" marL="0">
+              <a:buNone/>
+            </a:pPr>
+            <a:r>
+              <a:rPr lang="en-US" sz="1100" dirty="0">
                 <a:solidFill>
                   <a:schemeClr val="tx1"/>
                 </a:solidFill>
               </a:rPr>
-              <a:t>どこが変わったか、なぜ変わったかを自分の言葉で説明する</a:t>
-            </a:r>
-            <a:endParaRPr lang="en-US" sz="1150" dirty="0"/>
-          </a:p>
-        </p:txBody>
-      </p:sp>
-      <p:sp>
-        <p:nvSpPr>
-          <p:cNvPr id="20" name="Exercise info"/>
+              <a:t>資料を知らないClaudeの提案を、自分の情報で修正できるか</a:t>
+            </a:r>
+            <a:endParaRPr lang="en-US" sz="1100" dirty="0"/>
+          </a:p>
+        </p:txBody>
+      </p:sp>
+      <p:sp>
+        <p:nvSpPr>
+          <p:cNvPr id="21" name="Task info"/>
           <p:cNvSpPr/>
           <p:nvPr/>
         </p:nvSpPr>
         <p:spPr>
           <a:xfrm>
-            <a:off x="457200" y="3611880"/>
-            <a:ext cx="8229600" cy="960120"/>
+            <a:off x="457200" y="3840480"/>
+            <a:ext cx="8229600" cy="731520"/>
           </a:xfrm>
           <a:prstGeom prst="roundRect">
             <a:avLst>
-              <a:gd name="adj" fmla="val 11429"/>
+              <a:gd name="adj" fmla="val 15000"/>
             </a:avLst>
           </a:prstGeom>
           <a:solidFill>
@@ -4026,14 +4263,14 @@
       </p:sp>
       <p:sp>
         <p:nvSpPr>
-          <p:cNvPr id="21" name="Exercise text"/>
+          <p:cNvPr id="22" name="Task info text"/>
           <p:cNvSpPr txBox="1"/>
           <p:nvPr/>
         </p:nvSpPr>
         <p:spPr>
           <a:xfrm>
-            <a:off x="685800" y="3657600"/>
-            <a:ext cx="7772400" cy="868680"/>
+            <a:off x="685800" y="3886200"/>
+            <a:ext cx="7772400" cy="640080"/>
           </a:xfrm>
           <a:prstGeom prst="rect">
             <a:avLst/>
@@ -4046,44 +4283,35 @@
           <a:lstStyle/>
           <a:p>
             <a:pPr indent="0" marL="0">
-              <a:spcAft>
-                <a:spcPts val="400"/>
-              </a:spcAft>
-              <a:buNone/>
-            </a:pPr>
-            <a:r>
-              <a:rPr lang="en-US" sz="1250" b="1" dirty="0">
+              <a:buNone/>
+            </a:pPr>
+            <a:r>
+              <a:rPr lang="en-US" sz="1200" b="1" dirty="0">
                 <a:solidFill>
                   <a:schemeClr val="tx2"/>
                 </a:solidFill>
               </a:rPr>
-              <a:t>課題例　</a:t>
+              <a:t>提出物　</a:t>
             </a:r>
             <a:pPr indent="0" marL="0">
-              <a:spcAft>
-                <a:spcPts val="400"/>
-              </a:spcAft>
-              <a:buNone/>
-            </a:pPr>
-            <a:r>
-              <a:rPr lang="en-US" sz="1250" dirty="0">
+              <a:buNone/>
+            </a:pPr>
+            <a:r>
+              <a:rPr lang="en-US" sz="1200" dirty="0">
                 <a:solidFill>
                   <a:schemeClr val="tx1"/>
                 </a:solidFill>
               </a:rPr>
-              <a:t>「この社内文書を、全社員向けの案内メールに書き直して」</a:t>
-            </a:r>
-            <a:endParaRPr lang="en-US" sz="1250" dirty="0"/>
+              <a:t>仕上げたメール／Claudeへの依頼文／送付先の最終判断と理由</a:t>
+            </a:r>
+            <a:endParaRPr lang="en-US" sz="1200" dirty="0"/>
           </a:p>
           <a:p>
             <a:pPr indent="0" marL="0">
-              <a:spcAft>
-                <a:spcPts val="400"/>
-              </a:spcAft>
-              <a:buNone/>
-            </a:pPr>
-            <a:r>
-              <a:rPr lang="en-US" sz="1250" b="1" dirty="0">
+              <a:buNone/>
+            </a:pPr>
+            <a:r>
+              <a:rPr lang="en-US" sz="1200" b="1" dirty="0">
                 <a:solidFill>
                   <a:schemeClr val="tx2"/>
                 </a:solidFill>
@@ -4091,20 +4319,17 @@
               <a:t>所要時間　</a:t>
             </a:r>
             <a:pPr indent="0" marL="0">
-              <a:spcAft>
-                <a:spcPts val="400"/>
-              </a:spcAft>
-              <a:buNone/>
-            </a:pPr>
-            <a:r>
-              <a:rPr lang="en-US" sz="1250" dirty="0">
+              <a:buNone/>
+            </a:pPr>
+            <a:r>
+              <a:rPr lang="en-US" sz="1200" dirty="0">
                 <a:solidFill>
                   <a:schemeClr val="tx1"/>
                 </a:solidFill>
               </a:rPr>
-              <a:t>15分（各5分）。終了後、隣の人と結果を見せ合う</a:t>
-            </a:r>
-            <a:endParaRPr lang="en-US" sz="1250" dirty="0"/>
+              <a:t>30分（A 10分、B 10分、C 5分、記入5分）。自己申告ではなく、実際の行動で見る</a:t>
+            </a:r>
+            <a:endParaRPr lang="en-US" sz="1200" dirty="0"/>
           </a:p>
         </p:txBody>
       </p:sp>
@@ -4180,6 +4405,2292 @@
       </p:grpSpPr>
       <p:sp>
         <p:nvSpPr>
+          <p:cNvPr id="2" name="Text 0"/>
+          <p:cNvSpPr/>
+          <p:nvPr>
+            <p:ph idx="100" type="title" hasCustomPrompt="1"/>
+          </p:nvPr>
+        </p:nvSpPr>
+        <p:spPr>
+          <a:xfrm>
+            <a:off x="457200" y="320040"/>
+            <a:ext cx="8229600" cy="685800"/>
+          </a:xfrm>
+          <a:prstGeom prst="rect">
+            <a:avLst/>
+          </a:prstGeom>
+          <a:noFill/>
+          <a:ln/>
+        </p:spPr>
+        <p:txBody>
+          <a:bodyPr wrap="square" lIns="0" tIns="0" rIns="0" bIns="0" rtlCol="0" anchor="ctr"/>
+          <a:lstStyle/>
+          <a:p>
+            <a:pPr algn="l" indent="0" marL="0">
+              <a:buNone/>
+            </a:pPr>
+            <a:r>
+              <a:rPr lang="en-US" sz="2600" b="1" dirty="0">
+                <a:solidFill>
+                  <a:schemeClr val="tx2"/>
+                </a:solidFill>
+              </a:rPr>
+              <a:t>採点：8つの行動チェック</a:t>
+            </a:r>
+            <a:endParaRPr lang="en-US" sz="2600" dirty="0"/>
+          </a:p>
+        </p:txBody>
+      </p:sp>
+      <p:graphicFrame>
+        <p:nvGraphicFramePr>
+          <p:cNvPr id="14" name="Checklist table"/>
+          <p:cNvGraphicFramePr>
+            <a:graphicFrameLocks noGrp="1"/>
+          </p:cNvGraphicFramePr>
+          <p:nvPr>
+            <p:extLst>
+              <p:ext uri="{D42A27DB-BD31-4B8C-83A1-F6EECF244321}">
+                <p14:modId xmlns:p14="http://schemas.microsoft.com/office/powerpoint/2010/main" val="1579011935"/>
+              </p:ext>
+            </p:extLst>
+          </p:nvPr>
+        </p:nvGraphicFramePr>
+        <p:xfrm>
+          <a:off x="457200" y="1188720"/>
+          <a:ext cx="5212080" cy="914400"/>
+        </p:xfrm>
+        <a:graphic>
+          <a:graphicData uri="http://schemas.openxmlformats.org/drawingml/2006/table">
+            <a:tbl>
+              <a:tblPr/>
+              <a:tblGrid>
+                <a:gridCol w="640080"/>
+                <a:gridCol w="4572000"/>
+              </a:tblGrid>
+              <a:tr h="329184">
+                <a:tc>
+                  <a:txBody>
+                    <a:bodyPr/>
+                    <a:lstStyle/>
+                    <a:p>
+                      <a:pPr indent="0" marL="0">
+                        <a:buNone/>
+                      </a:pPr>
+                      <a:r>
+                        <a:rPr lang="en-US" sz="1100" b="1" dirty="0">
+                          <a:solidFill>
+                            <a:schemeClr val="tx2"/>
+                          </a:solidFill>
+                        </a:rPr>
+                        <a:t>項目</a:t>
+                      </a:r>
+                      <a:endParaRPr lang="en-US" sz="1100" dirty="0"/>
+                    </a:p>
+                  </a:txBody>
+                  <a:tcPr marL="73152" marR="73152" marT="27432" marB="27432" anchor="ctr">
+                    <a:lnL w="9525" cap="flat" cmpd="sng" algn="ctr">
+                      <a:solidFill>
+                        <a:srgbClr val="C9DEE2"/>
+                      </a:solidFill>
+                      <a:prstDash val="solid"/>
+                      <a:round/>
+                      <a:headEnd type="none" w="med" len="med"/>
+                      <a:tailEnd type="none" w="med" len="med"/>
+                    </a:lnL>
+                    <a:lnR w="9525" cap="flat" cmpd="sng" algn="ctr">
+                      <a:solidFill>
+                        <a:srgbClr val="C9DEE2"/>
+                      </a:solidFill>
+                      <a:prstDash val="solid"/>
+                      <a:round/>
+                      <a:headEnd type="none" w="med" len="med"/>
+                      <a:tailEnd type="none" w="med" len="med"/>
+                    </a:lnR>
+                    <a:lnT w="9525" cap="flat" cmpd="sng" algn="ctr">
+                      <a:solidFill>
+                        <a:srgbClr val="C9DEE2"/>
+                      </a:solidFill>
+                      <a:prstDash val="solid"/>
+                      <a:round/>
+                      <a:headEnd type="none" w="med" len="med"/>
+                      <a:tailEnd type="none" w="med" len="med"/>
+                    </a:lnT>
+                    <a:lnB w="9525" cap="flat" cmpd="sng" algn="ctr">
+                      <a:solidFill>
+                        <a:srgbClr val="C9DEE2"/>
+                      </a:solidFill>
+                      <a:prstDash val="solid"/>
+                      <a:round/>
+                      <a:headEnd type="none" w="med" len="med"/>
+                      <a:tailEnd type="none" w="med" len="med"/>
+                    </a:lnB>
+                    <a:solidFill>
+                      <a:schemeClr val="bg2"/>
+                    </a:solidFill>
+                  </a:tcPr>
+                </a:tc>
+                <a:tc>
+                  <a:txBody>
+                    <a:bodyPr/>
+                    <a:lstStyle/>
+                    <a:p>
+                      <a:pPr indent="0" marL="0">
+                        <a:buNone/>
+                      </a:pPr>
+                      <a:r>
+                        <a:rPr lang="en-US" sz="1100" b="1" dirty="0">
+                          <a:solidFill>
+                            <a:schemeClr val="tx2"/>
+                          </a:solidFill>
+                        </a:rPr>
+                        <a:t>見る行動</a:t>
+                      </a:r>
+                      <a:endParaRPr lang="en-US" sz="1100" dirty="0"/>
+                    </a:p>
+                  </a:txBody>
+                  <a:tcPr marL="73152" marR="73152" marT="27432" marB="27432" anchor="ctr">
+                    <a:lnL w="9525" cap="flat" cmpd="sng" algn="ctr">
+                      <a:solidFill>
+                        <a:srgbClr val="C9DEE2"/>
+                      </a:solidFill>
+                      <a:prstDash val="solid"/>
+                      <a:round/>
+                      <a:headEnd type="none" w="med" len="med"/>
+                      <a:tailEnd type="none" w="med" len="med"/>
+                    </a:lnL>
+                    <a:lnR w="9525" cap="flat" cmpd="sng" algn="ctr">
+                      <a:solidFill>
+                        <a:srgbClr val="C9DEE2"/>
+                      </a:solidFill>
+                      <a:prstDash val="solid"/>
+                      <a:round/>
+                      <a:headEnd type="none" w="med" len="med"/>
+                      <a:tailEnd type="none" w="med" len="med"/>
+                    </a:lnR>
+                    <a:lnT w="9525" cap="flat" cmpd="sng" algn="ctr">
+                      <a:solidFill>
+                        <a:srgbClr val="C9DEE2"/>
+                      </a:solidFill>
+                      <a:prstDash val="solid"/>
+                      <a:round/>
+                      <a:headEnd type="none" w="med" len="med"/>
+                      <a:tailEnd type="none" w="med" len="med"/>
+                    </a:lnT>
+                    <a:lnB w="9525" cap="flat" cmpd="sng" algn="ctr">
+                      <a:solidFill>
+                        <a:srgbClr val="C9DEE2"/>
+                      </a:solidFill>
+                      <a:prstDash val="solid"/>
+                      <a:round/>
+                      <a:headEnd type="none" w="med" len="med"/>
+                      <a:tailEnd type="none" w="med" len="med"/>
+                    </a:lnB>
+                    <a:solidFill>
+                      <a:schemeClr val="bg2"/>
+                    </a:solidFill>
+                  </a:tcPr>
+                </a:tc>
+              </a:tr>
+              <a:tr h="329184">
+                <a:tc>
+                  <a:txBody>
+                    <a:bodyPr/>
+                    <a:lstStyle/>
+                    <a:p>
+                      <a:pPr indent="0" marL="0">
+                        <a:buNone/>
+                      </a:pPr>
+                      <a:r>
+                        <a:rPr lang="en-US" sz="1100" dirty="0">
+                          <a:solidFill>
+                            <a:schemeClr val="tx1"/>
+                          </a:solidFill>
+                        </a:rPr>
+                        <a:t>A1</a:t>
+                      </a:r>
+                      <a:endParaRPr lang="en-US" sz="1100" dirty="0"/>
+                    </a:p>
+                  </a:txBody>
+                  <a:tcPr marL="73152" marR="73152" marT="27432" marB="27432" anchor="ctr">
+                    <a:lnL w="9525" cap="flat" cmpd="sng" algn="ctr">
+                      <a:solidFill>
+                        <a:srgbClr val="C9DEE2"/>
+                      </a:solidFill>
+                      <a:prstDash val="solid"/>
+                      <a:round/>
+                      <a:headEnd type="none" w="med" len="med"/>
+                      <a:tailEnd type="none" w="med" len="med"/>
+                    </a:lnL>
+                    <a:lnR w="9525" cap="flat" cmpd="sng" algn="ctr">
+                      <a:solidFill>
+                        <a:srgbClr val="C9DEE2"/>
+                      </a:solidFill>
+                      <a:prstDash val="solid"/>
+                      <a:round/>
+                      <a:headEnd type="none" w="med" len="med"/>
+                      <a:tailEnd type="none" w="med" len="med"/>
+                    </a:lnR>
+                    <a:lnT w="9525" cap="flat" cmpd="sng" algn="ctr">
+                      <a:solidFill>
+                        <a:srgbClr val="C9DEE2"/>
+                      </a:solidFill>
+                      <a:prstDash val="solid"/>
+                      <a:round/>
+                      <a:headEnd type="none" w="med" len="med"/>
+                      <a:tailEnd type="none" w="med" len="med"/>
+                    </a:lnT>
+                    <a:lnB w="9525" cap="flat" cmpd="sng" algn="ctr">
+                      <a:solidFill>
+                        <a:srgbClr val="C9DEE2"/>
+                      </a:solidFill>
+                      <a:prstDash val="solid"/>
+                      <a:round/>
+                      <a:headEnd type="none" w="med" len="med"/>
+                      <a:tailEnd type="none" w="med" len="med"/>
+                    </a:lnB>
+                  </a:tcPr>
+                </a:tc>
+                <a:tc>
+                  <a:txBody>
+                    <a:bodyPr/>
+                    <a:lstStyle/>
+                    <a:p>
+                      <a:pPr indent="0" marL="0">
+                        <a:buNone/>
+                      </a:pPr>
+                      <a:r>
+                        <a:rPr lang="en-US" sz="1100" dirty="0">
+                          <a:solidFill>
+                            <a:schemeClr val="tx1"/>
+                          </a:solidFill>
+                        </a:rPr>
+                        <a:t>仕込んだ誤りを2個以上見つけた</a:t>
+                      </a:r>
+                      <a:endParaRPr lang="en-US" sz="1100" dirty="0"/>
+                    </a:p>
+                  </a:txBody>
+                  <a:tcPr marL="73152" marR="73152" marT="27432" marB="27432" anchor="ctr">
+                    <a:lnL w="9525" cap="flat" cmpd="sng" algn="ctr">
+                      <a:solidFill>
+                        <a:srgbClr val="C9DEE2"/>
+                      </a:solidFill>
+                      <a:prstDash val="solid"/>
+                      <a:round/>
+                      <a:headEnd type="none" w="med" len="med"/>
+                      <a:tailEnd type="none" w="med" len="med"/>
+                    </a:lnL>
+                    <a:lnR w="9525" cap="flat" cmpd="sng" algn="ctr">
+                      <a:solidFill>
+                        <a:srgbClr val="C9DEE2"/>
+                      </a:solidFill>
+                      <a:prstDash val="solid"/>
+                      <a:round/>
+                      <a:headEnd type="none" w="med" len="med"/>
+                      <a:tailEnd type="none" w="med" len="med"/>
+                    </a:lnR>
+                    <a:lnT w="9525" cap="flat" cmpd="sng" algn="ctr">
+                      <a:solidFill>
+                        <a:srgbClr val="C9DEE2"/>
+                      </a:solidFill>
+                      <a:prstDash val="solid"/>
+                      <a:round/>
+                      <a:headEnd type="none" w="med" len="med"/>
+                      <a:tailEnd type="none" w="med" len="med"/>
+                    </a:lnT>
+                    <a:lnB w="9525" cap="flat" cmpd="sng" algn="ctr">
+                      <a:solidFill>
+                        <a:srgbClr val="C9DEE2"/>
+                      </a:solidFill>
+                      <a:prstDash val="solid"/>
+                      <a:round/>
+                      <a:headEnd type="none" w="med" len="med"/>
+                      <a:tailEnd type="none" w="med" len="med"/>
+                    </a:lnB>
+                  </a:tcPr>
+                </a:tc>
+              </a:tr>
+              <a:tr h="329184">
+                <a:tc>
+                  <a:txBody>
+                    <a:bodyPr/>
+                    <a:lstStyle/>
+                    <a:p>
+                      <a:pPr indent="0" marL="0">
+                        <a:buNone/>
+                      </a:pPr>
+                      <a:r>
+                        <a:rPr lang="en-US" sz="1100" dirty="0">
+                          <a:solidFill>
+                            <a:schemeClr val="tx1"/>
+                          </a:solidFill>
+                        </a:rPr>
+                        <a:t>A2</a:t>
+                      </a:r>
+                      <a:endParaRPr lang="en-US" sz="1100" dirty="0"/>
+                    </a:p>
+                  </a:txBody>
+                  <a:tcPr marL="73152" marR="73152" marT="27432" marB="27432" anchor="ctr">
+                    <a:lnL w="9525" cap="flat" cmpd="sng" algn="ctr">
+                      <a:solidFill>
+                        <a:srgbClr val="C9DEE2"/>
+                      </a:solidFill>
+                      <a:prstDash val="solid"/>
+                      <a:round/>
+                      <a:headEnd type="none" w="med" len="med"/>
+                      <a:tailEnd type="none" w="med" len="med"/>
+                    </a:lnL>
+                    <a:lnR w="9525" cap="flat" cmpd="sng" algn="ctr">
+                      <a:solidFill>
+                        <a:srgbClr val="C9DEE2"/>
+                      </a:solidFill>
+                      <a:prstDash val="solid"/>
+                      <a:round/>
+                      <a:headEnd type="none" w="med" len="med"/>
+                      <a:tailEnd type="none" w="med" len="med"/>
+                    </a:lnR>
+                    <a:lnT w="9525" cap="flat" cmpd="sng" algn="ctr">
+                      <a:solidFill>
+                        <a:srgbClr val="C9DEE2"/>
+                      </a:solidFill>
+                      <a:prstDash val="solid"/>
+                      <a:round/>
+                      <a:headEnd type="none" w="med" len="med"/>
+                      <a:tailEnd type="none" w="med" len="med"/>
+                    </a:lnT>
+                    <a:lnB w="9525" cap="flat" cmpd="sng" algn="ctr">
+                      <a:solidFill>
+                        <a:srgbClr val="C9DEE2"/>
+                      </a:solidFill>
+                      <a:prstDash val="solid"/>
+                      <a:round/>
+                      <a:headEnd type="none" w="med" len="med"/>
+                      <a:tailEnd type="none" w="med" len="med"/>
+                    </a:lnB>
+                  </a:tcPr>
+                </a:tc>
+                <a:tc>
+                  <a:txBody>
+                    <a:bodyPr/>
+                    <a:lstStyle/>
+                    <a:p>
+                      <a:pPr indent="0" marL="0">
+                        <a:buNone/>
+                      </a:pPr>
+                      <a:r>
+                        <a:rPr lang="en-US" sz="1100" dirty="0">
+                          <a:solidFill>
+                            <a:schemeClr val="tx1"/>
+                          </a:solidFill>
+                        </a:rPr>
+                        <a:t>元資料と照合した形跡がある</a:t>
+                      </a:r>
+                      <a:endParaRPr lang="en-US" sz="1100" dirty="0"/>
+                    </a:p>
+                  </a:txBody>
+                  <a:tcPr marL="73152" marR="73152" marT="27432" marB="27432" anchor="ctr">
+                    <a:lnL w="9525" cap="flat" cmpd="sng" algn="ctr">
+                      <a:solidFill>
+                        <a:srgbClr val="C9DEE2"/>
+                      </a:solidFill>
+                      <a:prstDash val="solid"/>
+                      <a:round/>
+                      <a:headEnd type="none" w="med" len="med"/>
+                      <a:tailEnd type="none" w="med" len="med"/>
+                    </a:lnL>
+                    <a:lnR w="9525" cap="flat" cmpd="sng" algn="ctr">
+                      <a:solidFill>
+                        <a:srgbClr val="C9DEE2"/>
+                      </a:solidFill>
+                      <a:prstDash val="solid"/>
+                      <a:round/>
+                      <a:headEnd type="none" w="med" len="med"/>
+                      <a:tailEnd type="none" w="med" len="med"/>
+                    </a:lnR>
+                    <a:lnT w="9525" cap="flat" cmpd="sng" algn="ctr">
+                      <a:solidFill>
+                        <a:srgbClr val="C9DEE2"/>
+                      </a:solidFill>
+                      <a:prstDash val="solid"/>
+                      <a:round/>
+                      <a:headEnd type="none" w="med" len="med"/>
+                      <a:tailEnd type="none" w="med" len="med"/>
+                    </a:lnT>
+                    <a:lnB w="9525" cap="flat" cmpd="sng" algn="ctr">
+                      <a:solidFill>
+                        <a:srgbClr val="C9DEE2"/>
+                      </a:solidFill>
+                      <a:prstDash val="solid"/>
+                      <a:round/>
+                      <a:headEnd type="none" w="med" len="med"/>
+                      <a:tailEnd type="none" w="med" len="med"/>
+                    </a:lnB>
+                  </a:tcPr>
+                </a:tc>
+              </a:tr>
+              <a:tr h="329184">
+                <a:tc>
+                  <a:txBody>
+                    <a:bodyPr/>
+                    <a:lstStyle/>
+                    <a:p>
+                      <a:pPr indent="0" marL="0">
+                        <a:buNone/>
+                      </a:pPr>
+                      <a:r>
+                        <a:rPr lang="en-US" sz="1100" dirty="0">
+                          <a:solidFill>
+                            <a:schemeClr val="tx1"/>
+                          </a:solidFill>
+                        </a:rPr>
+                        <a:t>A3</a:t>
+                      </a:r>
+                      <a:endParaRPr lang="en-US" sz="1100" dirty="0"/>
+                    </a:p>
+                  </a:txBody>
+                  <a:tcPr marL="73152" marR="73152" marT="27432" marB="27432" anchor="ctr">
+                    <a:lnL w="9525" cap="flat" cmpd="sng" algn="ctr">
+                      <a:solidFill>
+                        <a:srgbClr val="C9DEE2"/>
+                      </a:solidFill>
+                      <a:prstDash val="solid"/>
+                      <a:round/>
+                      <a:headEnd type="none" w="med" len="med"/>
+                      <a:tailEnd type="none" w="med" len="med"/>
+                    </a:lnL>
+                    <a:lnR w="9525" cap="flat" cmpd="sng" algn="ctr">
+                      <a:solidFill>
+                        <a:srgbClr val="C9DEE2"/>
+                      </a:solidFill>
+                      <a:prstDash val="solid"/>
+                      <a:round/>
+                      <a:headEnd type="none" w="med" len="med"/>
+                      <a:tailEnd type="none" w="med" len="med"/>
+                    </a:lnR>
+                    <a:lnT w="9525" cap="flat" cmpd="sng" algn="ctr">
+                      <a:solidFill>
+                        <a:srgbClr val="C9DEE2"/>
+                      </a:solidFill>
+                      <a:prstDash val="solid"/>
+                      <a:round/>
+                      <a:headEnd type="none" w="med" len="med"/>
+                      <a:tailEnd type="none" w="med" len="med"/>
+                    </a:lnT>
+                    <a:lnB w="9525" cap="flat" cmpd="sng" algn="ctr">
+                      <a:solidFill>
+                        <a:srgbClr val="C9DEE2"/>
+                      </a:solidFill>
+                      <a:prstDash val="solid"/>
+                      <a:round/>
+                      <a:headEnd type="none" w="med" len="med"/>
+                      <a:tailEnd type="none" w="med" len="med"/>
+                    </a:lnB>
+                  </a:tcPr>
+                </a:tc>
+                <a:tc>
+                  <a:txBody>
+                    <a:bodyPr/>
+                    <a:lstStyle/>
+                    <a:p>
+                      <a:pPr indent="0" marL="0">
+                        <a:buNone/>
+                      </a:pPr>
+                      <a:r>
+                        <a:rPr lang="en-US" sz="1100" dirty="0">
+                          <a:solidFill>
+                            <a:schemeClr val="tx1"/>
+                          </a:solidFill>
+                        </a:rPr>
+                        <a:t>Claudeに頼む際、元資料を渡した</a:t>
+                      </a:r>
+                      <a:endParaRPr lang="en-US" sz="1100" dirty="0"/>
+                    </a:p>
+                  </a:txBody>
+                  <a:tcPr marL="73152" marR="73152" marT="27432" marB="27432" anchor="ctr">
+                    <a:lnL w="9525" cap="flat" cmpd="sng" algn="ctr">
+                      <a:solidFill>
+                        <a:srgbClr val="C9DEE2"/>
+                      </a:solidFill>
+                      <a:prstDash val="solid"/>
+                      <a:round/>
+                      <a:headEnd type="none" w="med" len="med"/>
+                      <a:tailEnd type="none" w="med" len="med"/>
+                    </a:lnL>
+                    <a:lnR w="9525" cap="flat" cmpd="sng" algn="ctr">
+                      <a:solidFill>
+                        <a:srgbClr val="C9DEE2"/>
+                      </a:solidFill>
+                      <a:prstDash val="solid"/>
+                      <a:round/>
+                      <a:headEnd type="none" w="med" len="med"/>
+                      <a:tailEnd type="none" w="med" len="med"/>
+                    </a:lnR>
+                    <a:lnT w="9525" cap="flat" cmpd="sng" algn="ctr">
+                      <a:solidFill>
+                        <a:srgbClr val="C9DEE2"/>
+                      </a:solidFill>
+                      <a:prstDash val="solid"/>
+                      <a:round/>
+                      <a:headEnd type="none" w="med" len="med"/>
+                      <a:tailEnd type="none" w="med" len="med"/>
+                    </a:lnT>
+                    <a:lnB w="9525" cap="flat" cmpd="sng" algn="ctr">
+                      <a:solidFill>
+                        <a:srgbClr val="C9DEE2"/>
+                      </a:solidFill>
+                      <a:prstDash val="solid"/>
+                      <a:round/>
+                      <a:headEnd type="none" w="med" len="med"/>
+                      <a:tailEnd type="none" w="med" len="med"/>
+                    </a:lnB>
+                  </a:tcPr>
+                </a:tc>
+              </a:tr>
+              <a:tr h="329184">
+                <a:tc>
+                  <a:txBody>
+                    <a:bodyPr/>
+                    <a:lstStyle/>
+                    <a:p>
+                      <a:pPr indent="0" marL="0">
+                        <a:buNone/>
+                      </a:pPr>
+                      <a:r>
+                        <a:rPr lang="en-US" sz="1100" dirty="0">
+                          <a:solidFill>
+                            <a:schemeClr val="tx1"/>
+                          </a:solidFill>
+                        </a:rPr>
+                        <a:t>B1</a:t>
+                      </a:r>
+                      <a:endParaRPr lang="en-US" sz="1100" dirty="0"/>
+                    </a:p>
+                  </a:txBody>
+                  <a:tcPr marL="73152" marR="73152" marT="27432" marB="27432" anchor="ctr">
+                    <a:lnL w="9525" cap="flat" cmpd="sng" algn="ctr">
+                      <a:solidFill>
+                        <a:srgbClr val="C9DEE2"/>
+                      </a:solidFill>
+                      <a:prstDash val="solid"/>
+                      <a:round/>
+                      <a:headEnd type="none" w="med" len="med"/>
+                      <a:tailEnd type="none" w="med" len="med"/>
+                    </a:lnL>
+                    <a:lnR w="9525" cap="flat" cmpd="sng" algn="ctr">
+                      <a:solidFill>
+                        <a:srgbClr val="C9DEE2"/>
+                      </a:solidFill>
+                      <a:prstDash val="solid"/>
+                      <a:round/>
+                      <a:headEnd type="none" w="med" len="med"/>
+                      <a:tailEnd type="none" w="med" len="med"/>
+                    </a:lnR>
+                    <a:lnT w="9525" cap="flat" cmpd="sng" algn="ctr">
+                      <a:solidFill>
+                        <a:srgbClr val="C9DEE2"/>
+                      </a:solidFill>
+                      <a:prstDash val="solid"/>
+                      <a:round/>
+                      <a:headEnd type="none" w="med" len="med"/>
+                      <a:tailEnd type="none" w="med" len="med"/>
+                    </a:lnT>
+                    <a:lnB w="9525" cap="flat" cmpd="sng" algn="ctr">
+                      <a:solidFill>
+                        <a:srgbClr val="C9DEE2"/>
+                      </a:solidFill>
+                      <a:prstDash val="solid"/>
+                      <a:round/>
+                      <a:headEnd type="none" w="med" len="med"/>
+                      <a:tailEnd type="none" w="med" len="med"/>
+                    </a:lnB>
+                  </a:tcPr>
+                </a:tc>
+                <a:tc>
+                  <a:txBody>
+                    <a:bodyPr/>
+                    <a:lstStyle/>
+                    <a:p>
+                      <a:pPr indent="0" marL="0">
+                        <a:buNone/>
+                      </a:pPr>
+                      <a:r>
+                        <a:rPr lang="en-US" sz="1100" dirty="0">
+                          <a:solidFill>
+                            <a:schemeClr val="tx1"/>
+                          </a:solidFill>
+                        </a:rPr>
+                        <a:t>依頼文に目的（誰に、何のため）がある</a:t>
+                      </a:r>
+                      <a:endParaRPr lang="en-US" sz="1100" dirty="0"/>
+                    </a:p>
+                  </a:txBody>
+                  <a:tcPr marL="73152" marR="73152" marT="27432" marB="27432" anchor="ctr">
+                    <a:lnL w="9525" cap="flat" cmpd="sng" algn="ctr">
+                      <a:solidFill>
+                        <a:srgbClr val="C9DEE2"/>
+                      </a:solidFill>
+                      <a:prstDash val="solid"/>
+                      <a:round/>
+                      <a:headEnd type="none" w="med" len="med"/>
+                      <a:tailEnd type="none" w="med" len="med"/>
+                    </a:lnL>
+                    <a:lnR w="9525" cap="flat" cmpd="sng" algn="ctr">
+                      <a:solidFill>
+                        <a:srgbClr val="C9DEE2"/>
+                      </a:solidFill>
+                      <a:prstDash val="solid"/>
+                      <a:round/>
+                      <a:headEnd type="none" w="med" len="med"/>
+                      <a:tailEnd type="none" w="med" len="med"/>
+                    </a:lnR>
+                    <a:lnT w="9525" cap="flat" cmpd="sng" algn="ctr">
+                      <a:solidFill>
+                        <a:srgbClr val="C9DEE2"/>
+                      </a:solidFill>
+                      <a:prstDash val="solid"/>
+                      <a:round/>
+                      <a:headEnd type="none" w="med" len="med"/>
+                      <a:tailEnd type="none" w="med" len="med"/>
+                    </a:lnT>
+                    <a:lnB w="9525" cap="flat" cmpd="sng" algn="ctr">
+                      <a:solidFill>
+                        <a:srgbClr val="C9DEE2"/>
+                      </a:solidFill>
+                      <a:prstDash val="solid"/>
+                      <a:round/>
+                      <a:headEnd type="none" w="med" len="med"/>
+                      <a:tailEnd type="none" w="med" len="med"/>
+                    </a:lnB>
+                  </a:tcPr>
+                </a:tc>
+              </a:tr>
+              <a:tr h="329184">
+                <a:tc>
+                  <a:txBody>
+                    <a:bodyPr/>
+                    <a:lstStyle/>
+                    <a:p>
+                      <a:pPr indent="0" marL="0">
+                        <a:buNone/>
+                      </a:pPr>
+                      <a:r>
+                        <a:rPr lang="en-US" sz="1100" dirty="0">
+                          <a:solidFill>
+                            <a:schemeClr val="tx1"/>
+                          </a:solidFill>
+                        </a:rPr>
+                        <a:t>B2</a:t>
+                      </a:r>
+                      <a:endParaRPr lang="en-US" sz="1100" dirty="0"/>
+                    </a:p>
+                  </a:txBody>
+                  <a:tcPr marL="73152" marR="73152" marT="27432" marB="27432" anchor="ctr">
+                    <a:lnL w="9525" cap="flat" cmpd="sng" algn="ctr">
+                      <a:solidFill>
+                        <a:srgbClr val="C9DEE2"/>
+                      </a:solidFill>
+                      <a:prstDash val="solid"/>
+                      <a:round/>
+                      <a:headEnd type="none" w="med" len="med"/>
+                      <a:tailEnd type="none" w="med" len="med"/>
+                    </a:lnL>
+                    <a:lnR w="9525" cap="flat" cmpd="sng" algn="ctr">
+                      <a:solidFill>
+                        <a:srgbClr val="C9DEE2"/>
+                      </a:solidFill>
+                      <a:prstDash val="solid"/>
+                      <a:round/>
+                      <a:headEnd type="none" w="med" len="med"/>
+                      <a:tailEnd type="none" w="med" len="med"/>
+                    </a:lnR>
+                    <a:lnT w="9525" cap="flat" cmpd="sng" algn="ctr">
+                      <a:solidFill>
+                        <a:srgbClr val="C9DEE2"/>
+                      </a:solidFill>
+                      <a:prstDash val="solid"/>
+                      <a:round/>
+                      <a:headEnd type="none" w="med" len="med"/>
+                      <a:tailEnd type="none" w="med" len="med"/>
+                    </a:lnT>
+                    <a:lnB w="9525" cap="flat" cmpd="sng" algn="ctr">
+                      <a:solidFill>
+                        <a:srgbClr val="C9DEE2"/>
+                      </a:solidFill>
+                      <a:prstDash val="solid"/>
+                      <a:round/>
+                      <a:headEnd type="none" w="med" len="med"/>
+                      <a:tailEnd type="none" w="med" len="med"/>
+                    </a:lnB>
+                  </a:tcPr>
+                </a:tc>
+                <a:tc>
+                  <a:txBody>
+                    <a:bodyPr/>
+                    <a:lstStyle/>
+                    <a:p>
+                      <a:pPr indent="0" marL="0">
+                        <a:buNone/>
+                      </a:pPr>
+                      <a:r>
+                        <a:rPr lang="en-US" sz="1100" dirty="0">
+                          <a:solidFill>
+                            <a:schemeClr val="tx1"/>
+                          </a:solidFill>
+                        </a:rPr>
+                        <a:t>依頼文に文脈（不慣れ、Teams）がある</a:t>
+                      </a:r>
+                      <a:endParaRPr lang="en-US" sz="1100" dirty="0"/>
+                    </a:p>
+                  </a:txBody>
+                  <a:tcPr marL="73152" marR="73152" marT="27432" marB="27432" anchor="ctr">
+                    <a:lnL w="9525" cap="flat" cmpd="sng" algn="ctr">
+                      <a:solidFill>
+                        <a:srgbClr val="C9DEE2"/>
+                      </a:solidFill>
+                      <a:prstDash val="solid"/>
+                      <a:round/>
+                      <a:headEnd type="none" w="med" len="med"/>
+                      <a:tailEnd type="none" w="med" len="med"/>
+                    </a:lnL>
+                    <a:lnR w="9525" cap="flat" cmpd="sng" algn="ctr">
+                      <a:solidFill>
+                        <a:srgbClr val="C9DEE2"/>
+                      </a:solidFill>
+                      <a:prstDash val="solid"/>
+                      <a:round/>
+                      <a:headEnd type="none" w="med" len="med"/>
+                      <a:tailEnd type="none" w="med" len="med"/>
+                    </a:lnR>
+                    <a:lnT w="9525" cap="flat" cmpd="sng" algn="ctr">
+                      <a:solidFill>
+                        <a:srgbClr val="C9DEE2"/>
+                      </a:solidFill>
+                      <a:prstDash val="solid"/>
+                      <a:round/>
+                      <a:headEnd type="none" w="med" len="med"/>
+                      <a:tailEnd type="none" w="med" len="med"/>
+                    </a:lnT>
+                    <a:lnB w="9525" cap="flat" cmpd="sng" algn="ctr">
+                      <a:solidFill>
+                        <a:srgbClr val="C9DEE2"/>
+                      </a:solidFill>
+                      <a:prstDash val="solid"/>
+                      <a:round/>
+                      <a:headEnd type="none" w="med" len="med"/>
+                      <a:tailEnd type="none" w="med" len="med"/>
+                    </a:lnB>
+                  </a:tcPr>
+                </a:tc>
+              </a:tr>
+              <a:tr h="329184">
+                <a:tc>
+                  <a:txBody>
+                    <a:bodyPr/>
+                    <a:lstStyle/>
+                    <a:p>
+                      <a:pPr indent="0" marL="0">
+                        <a:buNone/>
+                      </a:pPr>
+                      <a:r>
+                        <a:rPr lang="en-US" sz="1100" dirty="0">
+                          <a:solidFill>
+                            <a:schemeClr val="tx1"/>
+                          </a:solidFill>
+                        </a:rPr>
+                        <a:t>B3</a:t>
+                      </a:r>
+                      <a:endParaRPr lang="en-US" sz="1100" dirty="0"/>
+                    </a:p>
+                  </a:txBody>
+                  <a:tcPr marL="73152" marR="73152" marT="27432" marB="27432" anchor="ctr">
+                    <a:lnL w="9525" cap="flat" cmpd="sng" algn="ctr">
+                      <a:solidFill>
+                        <a:srgbClr val="C9DEE2"/>
+                      </a:solidFill>
+                      <a:prstDash val="solid"/>
+                      <a:round/>
+                      <a:headEnd type="none" w="med" len="med"/>
+                      <a:tailEnd type="none" w="med" len="med"/>
+                    </a:lnL>
+                    <a:lnR w="9525" cap="flat" cmpd="sng" algn="ctr">
+                      <a:solidFill>
+                        <a:srgbClr val="C9DEE2"/>
+                      </a:solidFill>
+                      <a:prstDash val="solid"/>
+                      <a:round/>
+                      <a:headEnd type="none" w="med" len="med"/>
+                      <a:tailEnd type="none" w="med" len="med"/>
+                    </a:lnR>
+                    <a:lnT w="9525" cap="flat" cmpd="sng" algn="ctr">
+                      <a:solidFill>
+                        <a:srgbClr val="C9DEE2"/>
+                      </a:solidFill>
+                      <a:prstDash val="solid"/>
+                      <a:round/>
+                      <a:headEnd type="none" w="med" len="med"/>
+                      <a:tailEnd type="none" w="med" len="med"/>
+                    </a:lnT>
+                    <a:lnB w="9525" cap="flat" cmpd="sng" algn="ctr">
+                      <a:solidFill>
+                        <a:srgbClr val="C9DEE2"/>
+                      </a:solidFill>
+                      <a:prstDash val="solid"/>
+                      <a:round/>
+                      <a:headEnd type="none" w="med" len="med"/>
+                      <a:tailEnd type="none" w="med" len="med"/>
+                    </a:lnB>
+                  </a:tcPr>
+                </a:tc>
+                <a:tc>
+                  <a:txBody>
+                    <a:bodyPr/>
+                    <a:lstStyle/>
+                    <a:p>
+                      <a:pPr indent="0" marL="0">
+                        <a:buNone/>
+                      </a:pPr>
+                      <a:r>
+                        <a:rPr lang="en-US" sz="1100" dirty="0">
+                          <a:solidFill>
+                            <a:schemeClr val="tx1"/>
+                          </a:solidFill>
+                        </a:rPr>
+                        <a:t>依頼文に制約（時間、禁止事項、トーン）がある</a:t>
+                      </a:r>
+                      <a:endParaRPr lang="en-US" sz="1100" dirty="0"/>
+                    </a:p>
+                  </a:txBody>
+                  <a:tcPr marL="73152" marR="73152" marT="27432" marB="27432" anchor="ctr">
+                    <a:lnL w="9525" cap="flat" cmpd="sng" algn="ctr">
+                      <a:solidFill>
+                        <a:srgbClr val="C9DEE2"/>
+                      </a:solidFill>
+                      <a:prstDash val="solid"/>
+                      <a:round/>
+                      <a:headEnd type="none" w="med" len="med"/>
+                      <a:tailEnd type="none" w="med" len="med"/>
+                    </a:lnL>
+                    <a:lnR w="9525" cap="flat" cmpd="sng" algn="ctr">
+                      <a:solidFill>
+                        <a:srgbClr val="C9DEE2"/>
+                      </a:solidFill>
+                      <a:prstDash val="solid"/>
+                      <a:round/>
+                      <a:headEnd type="none" w="med" len="med"/>
+                      <a:tailEnd type="none" w="med" len="med"/>
+                    </a:lnR>
+                    <a:lnT w="9525" cap="flat" cmpd="sng" algn="ctr">
+                      <a:solidFill>
+                        <a:srgbClr val="C9DEE2"/>
+                      </a:solidFill>
+                      <a:prstDash val="solid"/>
+                      <a:round/>
+                      <a:headEnd type="none" w="med" len="med"/>
+                      <a:tailEnd type="none" w="med" len="med"/>
+                    </a:lnT>
+                    <a:lnB w="9525" cap="flat" cmpd="sng" algn="ctr">
+                      <a:solidFill>
+                        <a:srgbClr val="C9DEE2"/>
+                      </a:solidFill>
+                      <a:prstDash val="solid"/>
+                      <a:round/>
+                      <a:headEnd type="none" w="med" len="med"/>
+                      <a:tailEnd type="none" w="med" len="med"/>
+                    </a:lnB>
+                  </a:tcPr>
+                </a:tc>
+              </a:tr>
+              <a:tr h="329184">
+                <a:tc>
+                  <a:txBody>
+                    <a:bodyPr/>
+                    <a:lstStyle/>
+                    <a:p>
+                      <a:pPr indent="0" marL="0">
+                        <a:buNone/>
+                      </a:pPr>
+                      <a:r>
+                        <a:rPr lang="en-US" sz="1100" dirty="0">
+                          <a:solidFill>
+                            <a:schemeClr val="tx1"/>
+                          </a:solidFill>
+                        </a:rPr>
+                        <a:t>C1</a:t>
+                      </a:r>
+                      <a:endParaRPr lang="en-US" sz="1100" dirty="0"/>
+                    </a:p>
+                  </a:txBody>
+                  <a:tcPr marL="73152" marR="73152" marT="27432" marB="27432" anchor="ctr">
+                    <a:lnL w="9525" cap="flat" cmpd="sng" algn="ctr">
+                      <a:solidFill>
+                        <a:srgbClr val="C9DEE2"/>
+                      </a:solidFill>
+                      <a:prstDash val="solid"/>
+                      <a:round/>
+                      <a:headEnd type="none" w="med" len="med"/>
+                      <a:tailEnd type="none" w="med" len="med"/>
+                    </a:lnL>
+                    <a:lnR w="9525" cap="flat" cmpd="sng" algn="ctr">
+                      <a:solidFill>
+                        <a:srgbClr val="C9DEE2"/>
+                      </a:solidFill>
+                      <a:prstDash val="solid"/>
+                      <a:round/>
+                      <a:headEnd type="none" w="med" len="med"/>
+                      <a:tailEnd type="none" w="med" len="med"/>
+                    </a:lnR>
+                    <a:lnT w="9525" cap="flat" cmpd="sng" algn="ctr">
+                      <a:solidFill>
+                        <a:srgbClr val="C9DEE2"/>
+                      </a:solidFill>
+                      <a:prstDash val="solid"/>
+                      <a:round/>
+                      <a:headEnd type="none" w="med" len="med"/>
+                      <a:tailEnd type="none" w="med" len="med"/>
+                    </a:lnT>
+                    <a:lnB w="9525" cap="flat" cmpd="sng" algn="ctr">
+                      <a:solidFill>
+                        <a:srgbClr val="C9DEE2"/>
+                      </a:solidFill>
+                      <a:prstDash val="solid"/>
+                      <a:round/>
+                      <a:headEnd type="none" w="med" len="med"/>
+                      <a:tailEnd type="none" w="med" len="med"/>
+                    </a:lnB>
+                  </a:tcPr>
+                </a:tc>
+                <a:tc>
+                  <a:txBody>
+                    <a:bodyPr/>
+                    <a:lstStyle/>
+                    <a:p>
+                      <a:pPr indent="0" marL="0">
+                        <a:buNone/>
+                      </a:pPr>
+                      <a:r>
+                        <a:rPr lang="en-US" sz="1100" dirty="0">
+                          <a:solidFill>
+                            <a:schemeClr val="tx1"/>
+                          </a:solidFill>
+                        </a:rPr>
+                        <a:t>Claudeの提案と自分の判断が違う場合、理由を書けた</a:t>
+                      </a:r>
+                      <a:endParaRPr lang="en-US" sz="1100" dirty="0"/>
+                    </a:p>
+                  </a:txBody>
+                  <a:tcPr marL="73152" marR="73152" marT="27432" marB="27432" anchor="ctr">
+                    <a:lnL w="9525" cap="flat" cmpd="sng" algn="ctr">
+                      <a:solidFill>
+                        <a:srgbClr val="C9DEE2"/>
+                      </a:solidFill>
+                      <a:prstDash val="solid"/>
+                      <a:round/>
+                      <a:headEnd type="none" w="med" len="med"/>
+                      <a:tailEnd type="none" w="med" len="med"/>
+                    </a:lnL>
+                    <a:lnR w="9525" cap="flat" cmpd="sng" algn="ctr">
+                      <a:solidFill>
+                        <a:srgbClr val="C9DEE2"/>
+                      </a:solidFill>
+                      <a:prstDash val="solid"/>
+                      <a:round/>
+                      <a:headEnd type="none" w="med" len="med"/>
+                      <a:tailEnd type="none" w="med" len="med"/>
+                    </a:lnR>
+                    <a:lnT w="9525" cap="flat" cmpd="sng" algn="ctr">
+                      <a:solidFill>
+                        <a:srgbClr val="C9DEE2"/>
+                      </a:solidFill>
+                      <a:prstDash val="solid"/>
+                      <a:round/>
+                      <a:headEnd type="none" w="med" len="med"/>
+                      <a:tailEnd type="none" w="med" len="med"/>
+                    </a:lnT>
+                    <a:lnB w="9525" cap="flat" cmpd="sng" algn="ctr">
+                      <a:solidFill>
+                        <a:srgbClr val="C9DEE2"/>
+                      </a:solidFill>
+                      <a:prstDash val="solid"/>
+                      <a:round/>
+                      <a:headEnd type="none" w="med" len="med"/>
+                      <a:tailEnd type="none" w="med" len="med"/>
+                    </a:lnB>
+                  </a:tcPr>
+                </a:tc>
+              </a:tr>
+              <a:tr h="329184">
+                <a:tc>
+                  <a:txBody>
+                    <a:bodyPr/>
+                    <a:lstStyle/>
+                    <a:p>
+                      <a:pPr indent="0" marL="0">
+                        <a:buNone/>
+                      </a:pPr>
+                      <a:r>
+                        <a:rPr lang="en-US" sz="1100" dirty="0">
+                          <a:solidFill>
+                            <a:schemeClr val="tx1"/>
+                          </a:solidFill>
+                        </a:rPr>
+                        <a:t>C2</a:t>
+                      </a:r>
+                      <a:endParaRPr lang="en-US" sz="1100" dirty="0"/>
+                    </a:p>
+                  </a:txBody>
+                  <a:tcPr marL="73152" marR="73152" marT="27432" marB="27432" anchor="ctr">
+                    <a:lnL w="9525" cap="flat" cmpd="sng" algn="ctr">
+                      <a:solidFill>
+                        <a:srgbClr val="C9DEE2"/>
+                      </a:solidFill>
+                      <a:prstDash val="solid"/>
+                      <a:round/>
+                      <a:headEnd type="none" w="med" len="med"/>
+                      <a:tailEnd type="none" w="med" len="med"/>
+                    </a:lnL>
+                    <a:lnR w="9525" cap="flat" cmpd="sng" algn="ctr">
+                      <a:solidFill>
+                        <a:srgbClr val="C9DEE2"/>
+                      </a:solidFill>
+                      <a:prstDash val="solid"/>
+                      <a:round/>
+                      <a:headEnd type="none" w="med" len="med"/>
+                      <a:tailEnd type="none" w="med" len="med"/>
+                    </a:lnR>
+                    <a:lnT w="9525" cap="flat" cmpd="sng" algn="ctr">
+                      <a:solidFill>
+                        <a:srgbClr val="C9DEE2"/>
+                      </a:solidFill>
+                      <a:prstDash val="solid"/>
+                      <a:round/>
+                      <a:headEnd type="none" w="med" len="med"/>
+                      <a:tailEnd type="none" w="med" len="med"/>
+                    </a:lnT>
+                    <a:lnB w="9525" cap="flat" cmpd="sng" algn="ctr">
+                      <a:solidFill>
+                        <a:srgbClr val="C9DEE2"/>
+                      </a:solidFill>
+                      <a:prstDash val="solid"/>
+                      <a:round/>
+                      <a:headEnd type="none" w="med" len="med"/>
+                      <a:tailEnd type="none" w="med" len="med"/>
+                    </a:lnB>
+                  </a:tcPr>
+                </a:tc>
+                <a:tc>
+                  <a:txBody>
+                    <a:bodyPr/>
+                    <a:lstStyle/>
+                    <a:p>
+                      <a:pPr indent="0" marL="0">
+                        <a:buNone/>
+                      </a:pPr>
+                      <a:r>
+                        <a:rPr lang="en-US" sz="1100" dirty="0">
+                          <a:solidFill>
+                            <a:schemeClr val="tx1"/>
+                          </a:solidFill>
+                        </a:rPr>
+                        <a:t>送付先から役員と契約社員を除いた</a:t>
+                      </a:r>
+                      <a:endParaRPr lang="en-US" sz="1100" dirty="0"/>
+                    </a:p>
+                  </a:txBody>
+                  <a:tcPr marL="73152" marR="73152" marT="27432" marB="27432" anchor="ctr">
+                    <a:lnL w="9525" cap="flat" cmpd="sng" algn="ctr">
+                      <a:solidFill>
+                        <a:srgbClr val="C9DEE2"/>
+                      </a:solidFill>
+                      <a:prstDash val="solid"/>
+                      <a:round/>
+                      <a:headEnd type="none" w="med" len="med"/>
+                      <a:tailEnd type="none" w="med" len="med"/>
+                    </a:lnL>
+                    <a:lnR w="9525" cap="flat" cmpd="sng" algn="ctr">
+                      <a:solidFill>
+                        <a:srgbClr val="C9DEE2"/>
+                      </a:solidFill>
+                      <a:prstDash val="solid"/>
+                      <a:round/>
+                      <a:headEnd type="none" w="med" len="med"/>
+                      <a:tailEnd type="none" w="med" len="med"/>
+                    </a:lnR>
+                    <a:lnT w="9525" cap="flat" cmpd="sng" algn="ctr">
+                      <a:solidFill>
+                        <a:srgbClr val="C9DEE2"/>
+                      </a:solidFill>
+                      <a:prstDash val="solid"/>
+                      <a:round/>
+                      <a:headEnd type="none" w="med" len="med"/>
+                      <a:tailEnd type="none" w="med" len="med"/>
+                    </a:lnT>
+                    <a:lnB w="9525" cap="flat" cmpd="sng" algn="ctr">
+                      <a:solidFill>
+                        <a:srgbClr val="C9DEE2"/>
+                      </a:solidFill>
+                      <a:prstDash val="solid"/>
+                      <a:round/>
+                      <a:headEnd type="none" w="med" len="med"/>
+                      <a:tailEnd type="none" w="med" len="med"/>
+                    </a:lnB>
+                  </a:tcPr>
+                </a:tc>
+              </a:tr>
+            </a:tbl>
+          </a:graphicData>
+        </a:graphic>
+      </p:graphicFrame>
+      <p:sp>
+        <p:nvSpPr>
+          <p:cNvPr id="4" name="Band card 1"/>
+          <p:cNvSpPr/>
+          <p:nvPr/>
+        </p:nvSpPr>
+        <p:spPr>
+          <a:xfrm>
+            <a:off x="5943600" y="1188720"/>
+            <a:ext cx="2743200" cy="868680"/>
+          </a:xfrm>
+          <a:prstGeom prst="roundRect">
+            <a:avLst>
+              <a:gd name="adj" fmla="val 12632"/>
+            </a:avLst>
+          </a:prstGeom>
+          <a:solidFill>
+            <a:schemeClr val="bg2"/>
+          </a:solidFill>
+          <a:ln w="12700">
+            <a:solidFill>
+              <a:schemeClr val="bg2"/>
+            </a:solidFill>
+            <a:prstDash val="solid"/>
+          </a:ln>
+        </p:spPr>
+      </p:sp>
+      <p:sp>
+        <p:nvSpPr>
+          <p:cNvPr id="5" name="Band num 1"/>
+          <p:cNvSpPr txBox="1"/>
+          <p:nvPr/>
+        </p:nvSpPr>
+        <p:spPr>
+          <a:xfrm>
+            <a:off x="6126480" y="1280160"/>
+            <a:ext cx="2377440" cy="320040"/>
+          </a:xfrm>
+          <a:prstGeom prst="rect">
+            <a:avLst/>
+          </a:prstGeom>
+          <a:noFill/>
+          <a:ln/>
+        </p:spPr>
+        <p:txBody>
+          <a:bodyPr wrap="square" lIns="0" tIns="0" rIns="0" bIns="0" rtlCol="0" anchor="ctr"/>
+          <a:lstStyle/>
+          <a:p>
+            <a:pPr indent="0" marL="0">
+              <a:buNone/>
+            </a:pPr>
+            <a:r>
+              <a:rPr lang="en-US" sz="1500" b="1" dirty="0">
+                <a:solidFill>
+                  <a:schemeClr val="accent2"/>
+                </a:solidFill>
+              </a:rPr>
+              <a:t>6個以上</a:t>
+            </a:r>
+            <a:endParaRPr lang="en-US" sz="1500" dirty="0"/>
+          </a:p>
+        </p:txBody>
+      </p:sp>
+      <p:sp>
+        <p:nvSpPr>
+          <p:cNvPr id="6" name="Band desc 1"/>
+          <p:cNvSpPr txBox="1"/>
+          <p:nvPr/>
+        </p:nvSpPr>
+        <p:spPr>
+          <a:xfrm>
+            <a:off x="6126480" y="1600200"/>
+            <a:ext cx="2377440" cy="411480"/>
+          </a:xfrm>
+          <a:prstGeom prst="rect">
+            <a:avLst/>
+          </a:prstGeom>
+          <a:noFill/>
+          <a:ln/>
+        </p:spPr>
+        <p:txBody>
+          <a:bodyPr wrap="square" lIns="0" tIns="0" rIns="0" bIns="0" rtlCol="0" anchor="t"/>
+          <a:lstStyle/>
+          <a:p>
+            <a:pPr indent="0" marL="0">
+              <a:buNone/>
+            </a:pPr>
+            <a:r>
+              <a:rPr lang="en-US" sz="1050" dirty="0">
+                <a:solidFill>
+                  <a:schemeClr val="tx1"/>
+                </a:solidFill>
+              </a:rPr>
+              <a:t>AIを使う人の傾向</a:t>
+            </a:r>
+            <a:endParaRPr lang="en-US" sz="1050" dirty="0"/>
+          </a:p>
+        </p:txBody>
+      </p:sp>
+      <p:sp>
+        <p:nvSpPr>
+          <p:cNvPr id="7" name="Band card 2"/>
+          <p:cNvSpPr/>
+          <p:nvPr/>
+        </p:nvSpPr>
+        <p:spPr>
+          <a:xfrm>
+            <a:off x="5943600" y="2194560"/>
+            <a:ext cx="2743200" cy="868680"/>
+          </a:xfrm>
+          <a:prstGeom prst="roundRect">
+            <a:avLst>
+              <a:gd name="adj" fmla="val 12632"/>
+            </a:avLst>
+          </a:prstGeom>
+          <a:solidFill>
+            <a:schemeClr val="bg2"/>
+          </a:solidFill>
+          <a:ln w="12700">
+            <a:solidFill>
+              <a:schemeClr val="bg2"/>
+            </a:solidFill>
+            <a:prstDash val="solid"/>
+          </a:ln>
+        </p:spPr>
+      </p:sp>
+      <p:sp>
+        <p:nvSpPr>
+          <p:cNvPr id="8" name="Band num 2"/>
+          <p:cNvSpPr txBox="1"/>
+          <p:nvPr/>
+        </p:nvSpPr>
+        <p:spPr>
+          <a:xfrm>
+            <a:off x="6126480" y="2286000"/>
+            <a:ext cx="2377440" cy="320040"/>
+          </a:xfrm>
+          <a:prstGeom prst="rect">
+            <a:avLst/>
+          </a:prstGeom>
+          <a:noFill/>
+          <a:ln/>
+        </p:spPr>
+        <p:txBody>
+          <a:bodyPr wrap="square" lIns="0" tIns="0" rIns="0" bIns="0" rtlCol="0" anchor="ctr"/>
+          <a:lstStyle/>
+          <a:p>
+            <a:pPr indent="0" marL="0">
+              <a:buNone/>
+            </a:pPr>
+            <a:r>
+              <a:rPr lang="en-US" sz="1500" b="1" dirty="0">
+                <a:solidFill>
+                  <a:schemeClr val="accent4"/>
+                </a:solidFill>
+              </a:rPr>
+              <a:t>3〜5個</a:t>
+            </a:r>
+            <a:endParaRPr lang="en-US" sz="1500" dirty="0"/>
+          </a:p>
+        </p:txBody>
+      </p:sp>
+      <p:sp>
+        <p:nvSpPr>
+          <p:cNvPr id="9" name="Band desc 2"/>
+          <p:cNvSpPr txBox="1"/>
+          <p:nvPr/>
+        </p:nvSpPr>
+        <p:spPr>
+          <a:xfrm>
+            <a:off x="6126480" y="2606040"/>
+            <a:ext cx="2377440" cy="411480"/>
+          </a:xfrm>
+          <a:prstGeom prst="rect">
+            <a:avLst/>
+          </a:prstGeom>
+          <a:noFill/>
+          <a:ln/>
+        </p:spPr>
+        <p:txBody>
+          <a:bodyPr wrap="square" lIns="0" tIns="0" rIns="0" bIns="0" rtlCol="0" anchor="t"/>
+          <a:lstStyle/>
+          <a:p>
+            <a:pPr indent="0" marL="0">
+              <a:buNone/>
+            </a:pPr>
+            <a:r>
+              <a:rPr lang="en-US" sz="1050" dirty="0">
+                <a:solidFill>
+                  <a:schemeClr val="tx1"/>
+                </a:solidFill>
+              </a:rPr>
+              <a:t>中間。×が集中した区分を本人に伝える</a:t>
+            </a:r>
+            <a:endParaRPr lang="en-US" sz="1050" dirty="0"/>
+          </a:p>
+        </p:txBody>
+      </p:sp>
+      <p:sp>
+        <p:nvSpPr>
+          <p:cNvPr id="10" name="Band card 3"/>
+          <p:cNvSpPr/>
+          <p:nvPr/>
+        </p:nvSpPr>
+        <p:spPr>
+          <a:xfrm>
+            <a:off x="5943600" y="3200400"/>
+            <a:ext cx="2743200" cy="868680"/>
+          </a:xfrm>
+          <a:prstGeom prst="roundRect">
+            <a:avLst>
+              <a:gd name="adj" fmla="val 12632"/>
+            </a:avLst>
+          </a:prstGeom>
+          <a:solidFill>
+            <a:schemeClr val="bg2"/>
+          </a:solidFill>
+          <a:ln w="12700">
+            <a:solidFill>
+              <a:schemeClr val="bg2"/>
+            </a:solidFill>
+            <a:prstDash val="solid"/>
+          </a:ln>
+        </p:spPr>
+      </p:sp>
+      <p:sp>
+        <p:nvSpPr>
+          <p:cNvPr id="11" name="Band num 3"/>
+          <p:cNvSpPr txBox="1"/>
+          <p:nvPr/>
+        </p:nvSpPr>
+        <p:spPr>
+          <a:xfrm>
+            <a:off x="6126480" y="3291840"/>
+            <a:ext cx="2377440" cy="320040"/>
+          </a:xfrm>
+          <a:prstGeom prst="rect">
+            <a:avLst/>
+          </a:prstGeom>
+          <a:noFill/>
+          <a:ln/>
+        </p:spPr>
+        <p:txBody>
+          <a:bodyPr wrap="square" lIns="0" tIns="0" rIns="0" bIns="0" rtlCol="0" anchor="ctr"/>
+          <a:lstStyle/>
+          <a:p>
+            <a:pPr indent="0" marL="0">
+              <a:buNone/>
+            </a:pPr>
+            <a:r>
+              <a:rPr lang="en-US" sz="1500" b="1" dirty="0">
+                <a:solidFill>
+                  <a:schemeClr val="accent3"/>
+                </a:solidFill>
+              </a:rPr>
+              <a:t>2個以下</a:t>
+            </a:r>
+            <a:endParaRPr lang="en-US" sz="1500" dirty="0"/>
+          </a:p>
+        </p:txBody>
+      </p:sp>
+      <p:sp>
+        <p:nvSpPr>
+          <p:cNvPr id="12" name="Band desc 3"/>
+          <p:cNvSpPr txBox="1"/>
+          <p:nvPr/>
+        </p:nvSpPr>
+        <p:spPr>
+          <a:xfrm>
+            <a:off x="6126480" y="3611880"/>
+            <a:ext cx="2377440" cy="411480"/>
+          </a:xfrm>
+          <a:prstGeom prst="rect">
+            <a:avLst/>
+          </a:prstGeom>
+          <a:noFill/>
+          <a:ln/>
+        </p:spPr>
+        <p:txBody>
+          <a:bodyPr wrap="square" lIns="0" tIns="0" rIns="0" bIns="0" rtlCol="0" anchor="t"/>
+          <a:lstStyle/>
+          <a:p>
+            <a:pPr indent="0" marL="0">
+              <a:buNone/>
+            </a:pPr>
+            <a:r>
+              <a:rPr lang="en-US" sz="1050" dirty="0">
+                <a:solidFill>
+                  <a:schemeClr val="tx1"/>
+                </a:solidFill>
+              </a:rPr>
+              <a:t>AIに使われる人の傾向。まず種明かしで体感してもらう</a:t>
+            </a:r>
+            <a:endParaRPr lang="en-US" sz="1050" dirty="0"/>
+          </a:p>
+        </p:txBody>
+      </p:sp>
+      <p:sp>
+        <p:nvSpPr>
+          <p:cNvPr id="13" name="Scoring note"/>
+          <p:cNvSpPr txBox="1"/>
+          <p:nvPr/>
+        </p:nvSpPr>
+        <p:spPr>
+          <a:xfrm>
+            <a:off x="457200" y="4251960"/>
+            <a:ext cx="8229600" cy="365760"/>
+          </a:xfrm>
+          <a:prstGeom prst="rect">
+            <a:avLst/>
+          </a:prstGeom>
+          <a:noFill/>
+          <a:ln/>
+        </p:spPr>
+        <p:txBody>
+          <a:bodyPr wrap="square" lIns="0" tIns="0" rIns="0" bIns="0" rtlCol="0" anchor="ctr"/>
+          <a:lstStyle/>
+          <a:p>
+            <a:pPr indent="0" marL="0">
+              <a:buNone/>
+            </a:pPr>
+            <a:r>
+              <a:rPr lang="en-US" sz="1200" i="1" dirty="0">
+                <a:solidFill>
+                  <a:schemeClr val="accent1"/>
+                </a:solidFill>
+              </a:rPr>
+              <a:t>結果は「タイプ」ではなく「今の傾向」として返す。ラベルを貼ると防御反応が出て、講義が入らなくなる</a:t>
+            </a:r>
+            <a:endParaRPr lang="en-US" sz="1200" dirty="0"/>
+          </a:p>
+        </p:txBody>
+      </p:sp>
+      <p:sp>
+        <p:nvSpPr>
+          <p:cNvPr id="25" name="Slide Number Placeholder 0"/>
+          <p:cNvSpPr>
+            <a:spLocks noGrp="1"/>
+          </p:cNvSpPr>
+          <p:nvPr>
+            <p:ph type="sldNum" sz="quarter" idx="4294967295"/>
+          </p:nvPr>
+        </p:nvSpPr>
+        <p:spPr>
+          <a:xfrm>
+            <a:off x="8229600" y="4754880"/>
+            <a:ext cx="457200" cy="274320"/>
+          </a:xfrm>
+          <a:prstGeom prst="rect">
+            <a:avLst/>
+          </a:prstGeom>
+          <a:extLst>
+            <a:ext uri="{C572A759-6A51-4108-AA02-DFA0A04FC94B}">
+              <ma14:wrappingTextBoxFlag xmlns:ma14="http://schemas.microsoft.com/office/mac/drawingml/2011/main" val="0"/>
+            </a:ext>
+          </a:extLst>
+        </p:spPr>
+        <p:txBody>
+          <a:bodyPr/>
+          <a:lstStyle>
+            <a:lvl1pPr>
+              <a:defRPr sz="900">
+                <a:solidFill>
+                  <a:schemeClr val="accent4"/>
+                </a:solidFill>
+              </a:defRPr>
+            </a:lvl1pPr>
+          </a:lstStyle>
+          <a:p>
+            <a:pPr algn="r"/>
+            <a:fld id="{F7021451-1387-4CA6-816F-3879F97B5CBC}" type="slidenum">
+              <a:rPr b="0" lang="en-US"/>
+              <a:t>13</a:t>
+            </a:fld>
+            <a:endParaRPr lang="en-US"/>
+          </a:p>
+        </p:txBody>
+      </p:sp>
+    </p:spTree>
+  </p:cSld>
+  <p:clrMapOvr>
+    <a:masterClrMapping/>
+  </p:clrMapOvr>
+</p:sld>
+</file>
+
+<file path=ppt/slides/slide14.xml><?xml version="1.0" encoding="utf-8"?>
+<p:sld xmlns:a="http://schemas.openxmlformats.org/drawingml/2006/main" xmlns:r="http://schemas.openxmlformats.org/officeDocument/2006/relationships" xmlns:p="http://schemas.openxmlformats.org/presentationml/2006/main">
+  <p:cSld name="Slide 14">
+    <p:spTree>
+      <p:nvGrpSpPr>
+        <p:cNvPr id="1" name=""/>
+        <p:cNvGrpSpPr/>
+        <p:nvPr/>
+      </p:nvGrpSpPr>
+      <p:grpSpPr>
+        <a:xfrm>
+          <a:off x="0" y="0"/>
+          <a:ext cx="0" cy="0"/>
+          <a:chOff x="0" y="0"/>
+          <a:chExt cx="0" cy="0"/>
+        </a:xfrm>
+      </p:grpSpPr>
+      <p:sp>
+        <p:nvSpPr>
+          <p:cNvPr id="2" name="Text 0"/>
+          <p:cNvSpPr/>
+          <p:nvPr>
+            <p:ph idx="100" type="title" hasCustomPrompt="1"/>
+          </p:nvPr>
+        </p:nvSpPr>
+        <p:spPr>
+          <a:xfrm>
+            <a:off x="457200" y="320040"/>
+            <a:ext cx="8229600" cy="685800"/>
+          </a:xfrm>
+          <a:prstGeom prst="rect">
+            <a:avLst/>
+          </a:prstGeom>
+          <a:noFill/>
+          <a:ln/>
+        </p:spPr>
+        <p:txBody>
+          <a:bodyPr wrap="square" lIns="0" tIns="0" rIns="0" bIns="0" rtlCol="0" anchor="ctr"/>
+          <a:lstStyle/>
+          <a:p>
+            <a:pPr algn="l" indent="0" marL="0">
+              <a:buNone/>
+            </a:pPr>
+            <a:r>
+              <a:rPr lang="en-US" sz="2600" b="1" dirty="0">
+                <a:solidFill>
+                  <a:schemeClr val="tx2"/>
+                </a:solidFill>
+              </a:rPr>
+              <a:t>演習：同じ課題を2通りの指示で試す</a:t>
+            </a:r>
+            <a:endParaRPr lang="en-US" sz="2600" dirty="0"/>
+          </a:p>
+        </p:txBody>
+      </p:sp>
+      <p:sp>
+        <p:nvSpPr>
+          <p:cNvPr id="3" name="Step card 1"/>
+          <p:cNvSpPr/>
+          <p:nvPr/>
+        </p:nvSpPr>
+        <p:spPr>
+          <a:xfrm>
+            <a:off x="457200" y="1188720"/>
+            <a:ext cx="2514600" cy="2194560"/>
+          </a:xfrm>
+          <a:prstGeom prst="roundRect">
+            <a:avLst>
+              <a:gd name="adj" fmla="val 5000"/>
+            </a:avLst>
+          </a:prstGeom>
+          <a:solidFill>
+            <a:schemeClr val="bg2"/>
+          </a:solidFill>
+          <a:ln w="12700">
+            <a:solidFill>
+              <a:schemeClr val="bg2"/>
+            </a:solidFill>
+            <a:prstDash val="solid"/>
+          </a:ln>
+        </p:spPr>
+      </p:sp>
+      <p:sp>
+        <p:nvSpPr>
+          <p:cNvPr id="4" name="Step circle 1"/>
+          <p:cNvSpPr/>
+          <p:nvPr/>
+        </p:nvSpPr>
+        <p:spPr>
+          <a:xfrm>
+            <a:off x="685800" y="1417320"/>
+            <a:ext cx="594360" cy="594360"/>
+          </a:xfrm>
+          <a:prstGeom prst="ellipse">
+            <a:avLst/>
+          </a:prstGeom>
+          <a:solidFill>
+            <a:schemeClr val="accent1"/>
+          </a:solidFill>
+          <a:ln w="12700">
+            <a:solidFill>
+              <a:schemeClr val="accent1"/>
+            </a:solidFill>
+            <a:prstDash val="solid"/>
+          </a:ln>
+        </p:spPr>
+      </p:sp>
+      <p:sp>
+        <p:nvSpPr>
+          <p:cNvPr id="5" name="Step num 1"/>
+          <p:cNvSpPr txBox="1"/>
+          <p:nvPr/>
+        </p:nvSpPr>
+        <p:spPr>
+          <a:xfrm>
+            <a:off x="685800" y="1417320"/>
+            <a:ext cx="594360" cy="594360"/>
+          </a:xfrm>
+          <a:prstGeom prst="rect">
+            <a:avLst/>
+          </a:prstGeom>
+          <a:noFill/>
+          <a:ln/>
+        </p:spPr>
+        <p:txBody>
+          <a:bodyPr wrap="square" lIns="0" tIns="0" rIns="0" bIns="0" rtlCol="0" anchor="ctr"/>
+          <a:lstStyle/>
+          <a:p>
+            <a:pPr algn="ctr" indent="0" marL="0">
+              <a:buNone/>
+            </a:pPr>
+            <a:r>
+              <a:rPr lang="en-US" sz="2200" b="1" dirty="0">
+                <a:solidFill>
+                  <a:schemeClr val="bg1"/>
+                </a:solidFill>
+              </a:rPr>
+              <a:t>1</a:t>
+            </a:r>
+            <a:endParaRPr lang="en-US" sz="2200" dirty="0"/>
+          </a:p>
+        </p:txBody>
+      </p:sp>
+      <p:sp>
+        <p:nvSpPr>
+          <p:cNvPr id="6" name="Step head 1"/>
+          <p:cNvSpPr txBox="1"/>
+          <p:nvPr/>
+        </p:nvSpPr>
+        <p:spPr>
+          <a:xfrm>
+            <a:off x="685800" y="2148840"/>
+            <a:ext cx="2057400" cy="548640"/>
+          </a:xfrm>
+          <a:prstGeom prst="rect">
+            <a:avLst/>
+          </a:prstGeom>
+          <a:noFill/>
+          <a:ln/>
+        </p:spPr>
+        <p:txBody>
+          <a:bodyPr wrap="square" lIns="0" tIns="0" rIns="0" bIns="0" rtlCol="0" anchor="t"/>
+          <a:lstStyle/>
+          <a:p>
+            <a:pPr indent="0" marL="0">
+              <a:buNone/>
+            </a:pPr>
+            <a:r>
+              <a:rPr lang="en-US" sz="1400" b="1" dirty="0">
+                <a:solidFill>
+                  <a:schemeClr val="tx2"/>
+                </a:solidFill>
+              </a:rPr>
+              <a:t>一行で頼む</a:t>
+            </a:r>
+            <a:endParaRPr lang="en-US" sz="1400" dirty="0"/>
+          </a:p>
+        </p:txBody>
+      </p:sp>
+      <p:sp>
+        <p:nvSpPr>
+          <p:cNvPr id="7" name="Step desc 1"/>
+          <p:cNvSpPr txBox="1"/>
+          <p:nvPr/>
+        </p:nvSpPr>
+        <p:spPr>
+          <a:xfrm>
+            <a:off x="685800" y="2743200"/>
+            <a:ext cx="2057400" cy="594360"/>
+          </a:xfrm>
+          <a:prstGeom prst="rect">
+            <a:avLst/>
+          </a:prstGeom>
+          <a:noFill/>
+          <a:ln/>
+        </p:spPr>
+        <p:txBody>
+          <a:bodyPr wrap="square" lIns="0" tIns="0" rIns="0" bIns="0" rtlCol="0" anchor="t"/>
+          <a:lstStyle/>
+          <a:p>
+            <a:pPr indent="0" marL="0">
+              <a:buNone/>
+            </a:pPr>
+            <a:r>
+              <a:rPr lang="en-US" sz="1150" dirty="0">
+                <a:solidFill>
+                  <a:schemeClr val="tx1"/>
+                </a:solidFill>
+              </a:rPr>
+              <a:t>まず「いい感じに」のような短い指示で出力を得る</a:t>
+            </a:r>
+            <a:endParaRPr lang="en-US" sz="1150" dirty="0"/>
+          </a:p>
+        </p:txBody>
+      </p:sp>
+      <p:pic>
+        <p:nvPicPr>
+          <p:cNvPr id="8" name="Step arrow 1" descr="preencoded.png">    </p:cNvPr>
+          <p:cNvPicPr>
+            <a:picLocks noChangeAspect="1"/>
+          </p:cNvPicPr>
+          <p:nvPr/>
+        </p:nvPicPr>
+        <p:blipFill>
+          <a:blip r:embed="rId1"/>
+          <a:stretch>
+            <a:fillRect/>
+          </a:stretch>
+        </p:blipFill>
+        <p:spPr>
+          <a:xfrm>
+            <a:off x="3017520" y="2057400"/>
+            <a:ext cx="256032" cy="256032"/>
+          </a:xfrm>
+          <a:prstGeom prst="rect">
+            <a:avLst/>
+          </a:prstGeom>
+        </p:spPr>
+      </p:pic>
+      <p:sp>
+        <p:nvSpPr>
+          <p:cNvPr id="9" name="Step card 2"/>
+          <p:cNvSpPr/>
+          <p:nvPr/>
+        </p:nvSpPr>
+        <p:spPr>
+          <a:xfrm>
+            <a:off x="3314700" y="1188720"/>
+            <a:ext cx="2514600" cy="2194560"/>
+          </a:xfrm>
+          <a:prstGeom prst="roundRect">
+            <a:avLst>
+              <a:gd name="adj" fmla="val 5000"/>
+            </a:avLst>
+          </a:prstGeom>
+          <a:solidFill>
+            <a:schemeClr val="bg2"/>
+          </a:solidFill>
+          <a:ln w="12700">
+            <a:solidFill>
+              <a:schemeClr val="bg2"/>
+            </a:solidFill>
+            <a:prstDash val="solid"/>
+          </a:ln>
+        </p:spPr>
+      </p:sp>
+      <p:sp>
+        <p:nvSpPr>
+          <p:cNvPr id="10" name="Step circle 2"/>
+          <p:cNvSpPr/>
+          <p:nvPr/>
+        </p:nvSpPr>
+        <p:spPr>
+          <a:xfrm>
+            <a:off x="3543300" y="1417320"/>
+            <a:ext cx="594360" cy="594360"/>
+          </a:xfrm>
+          <a:prstGeom prst="ellipse">
+            <a:avLst/>
+          </a:prstGeom>
+          <a:solidFill>
+            <a:schemeClr val="accent1"/>
+          </a:solidFill>
+          <a:ln w="12700">
+            <a:solidFill>
+              <a:schemeClr val="accent1"/>
+            </a:solidFill>
+            <a:prstDash val="solid"/>
+          </a:ln>
+        </p:spPr>
+      </p:sp>
+      <p:sp>
+        <p:nvSpPr>
+          <p:cNvPr id="11" name="Step num 2"/>
+          <p:cNvSpPr txBox="1"/>
+          <p:nvPr/>
+        </p:nvSpPr>
+        <p:spPr>
+          <a:xfrm>
+            <a:off x="3543300" y="1417320"/>
+            <a:ext cx="594360" cy="594360"/>
+          </a:xfrm>
+          <a:prstGeom prst="rect">
+            <a:avLst/>
+          </a:prstGeom>
+          <a:noFill/>
+          <a:ln/>
+        </p:spPr>
+        <p:txBody>
+          <a:bodyPr wrap="square" lIns="0" tIns="0" rIns="0" bIns="0" rtlCol="0" anchor="ctr"/>
+          <a:lstStyle/>
+          <a:p>
+            <a:pPr algn="ctr" indent="0" marL="0">
+              <a:buNone/>
+            </a:pPr>
+            <a:r>
+              <a:rPr lang="en-US" sz="2200" b="1" dirty="0">
+                <a:solidFill>
+                  <a:schemeClr val="bg1"/>
+                </a:solidFill>
+              </a:rPr>
+              <a:t>2</a:t>
+            </a:r>
+            <a:endParaRPr lang="en-US" sz="2200" dirty="0"/>
+          </a:p>
+        </p:txBody>
+      </p:sp>
+      <p:sp>
+        <p:nvSpPr>
+          <p:cNvPr id="12" name="Step head 2"/>
+          <p:cNvSpPr txBox="1"/>
+          <p:nvPr/>
+        </p:nvSpPr>
+        <p:spPr>
+          <a:xfrm>
+            <a:off x="3543300" y="2148840"/>
+            <a:ext cx="2057400" cy="548640"/>
+          </a:xfrm>
+          <a:prstGeom prst="rect">
+            <a:avLst/>
+          </a:prstGeom>
+          <a:noFill/>
+          <a:ln/>
+        </p:spPr>
+        <p:txBody>
+          <a:bodyPr wrap="square" lIns="0" tIns="0" rIns="0" bIns="0" rtlCol="0" anchor="t"/>
+          <a:lstStyle/>
+          <a:p>
+            <a:pPr indent="0" marL="0">
+              <a:buNone/>
+            </a:pPr>
+            <a:r>
+              <a:rPr lang="en-US" sz="1400" b="1" dirty="0">
+                <a:solidFill>
+                  <a:schemeClr val="tx2"/>
+                </a:solidFill>
+              </a:rPr>
+              <a:t>目的・文脈・制約を添えて頼む</a:t>
+            </a:r>
+            <a:endParaRPr lang="en-US" sz="1400" dirty="0"/>
+          </a:p>
+        </p:txBody>
+      </p:sp>
+      <p:sp>
+        <p:nvSpPr>
+          <p:cNvPr id="13" name="Step desc 2"/>
+          <p:cNvSpPr txBox="1"/>
+          <p:nvPr/>
+        </p:nvSpPr>
+        <p:spPr>
+          <a:xfrm>
+            <a:off x="3543300" y="2743200"/>
+            <a:ext cx="2057400" cy="594360"/>
+          </a:xfrm>
+          <a:prstGeom prst="rect">
+            <a:avLst/>
+          </a:prstGeom>
+          <a:noFill/>
+          <a:ln/>
+        </p:spPr>
+        <p:txBody>
+          <a:bodyPr wrap="square" lIns="0" tIns="0" rIns="0" bIns="0" rtlCol="0" anchor="t"/>
+          <a:lstStyle/>
+          <a:p>
+            <a:pPr indent="0" marL="0">
+              <a:buNone/>
+            </a:pPr>
+            <a:r>
+              <a:rPr lang="en-US" sz="1150" dirty="0">
+                <a:solidFill>
+                  <a:schemeClr val="tx1"/>
+                </a:solidFill>
+              </a:rPr>
+              <a:t>誰向けか、何に使うか、長さや形式の条件を書いて同じ課題を頼む</a:t>
+            </a:r>
+            <a:endParaRPr lang="en-US" sz="1150" dirty="0"/>
+          </a:p>
+        </p:txBody>
+      </p:sp>
+      <p:pic>
+        <p:nvPicPr>
+          <p:cNvPr id="14" name="Step arrow 2" descr="preencoded.png">    </p:cNvPr>
+          <p:cNvPicPr>
+            <a:picLocks noChangeAspect="1"/>
+          </p:cNvPicPr>
+          <p:nvPr/>
+        </p:nvPicPr>
+        <p:blipFill>
+          <a:blip r:embed="rId2"/>
+          <a:stretch>
+            <a:fillRect/>
+          </a:stretch>
+        </p:blipFill>
+        <p:spPr>
+          <a:xfrm>
+            <a:off x="5875020" y="2057400"/>
+            <a:ext cx="256032" cy="256032"/>
+          </a:xfrm>
+          <a:prstGeom prst="rect">
+            <a:avLst/>
+          </a:prstGeom>
+        </p:spPr>
+      </p:pic>
+      <p:sp>
+        <p:nvSpPr>
+          <p:cNvPr id="15" name="Step card 3"/>
+          <p:cNvSpPr/>
+          <p:nvPr/>
+        </p:nvSpPr>
+        <p:spPr>
+          <a:xfrm>
+            <a:off x="6172200" y="1188720"/>
+            <a:ext cx="2514600" cy="2194560"/>
+          </a:xfrm>
+          <a:prstGeom prst="roundRect">
+            <a:avLst>
+              <a:gd name="adj" fmla="val 5000"/>
+            </a:avLst>
+          </a:prstGeom>
+          <a:solidFill>
+            <a:schemeClr val="bg2"/>
+          </a:solidFill>
+          <a:ln w="12700">
+            <a:solidFill>
+              <a:schemeClr val="bg2"/>
+            </a:solidFill>
+            <a:prstDash val="solid"/>
+          </a:ln>
+        </p:spPr>
+      </p:sp>
+      <p:sp>
+        <p:nvSpPr>
+          <p:cNvPr id="16" name="Step circle 3"/>
+          <p:cNvSpPr/>
+          <p:nvPr/>
+        </p:nvSpPr>
+        <p:spPr>
+          <a:xfrm>
+            <a:off x="6400800" y="1417320"/>
+            <a:ext cx="594360" cy="594360"/>
+          </a:xfrm>
+          <a:prstGeom prst="ellipse">
+            <a:avLst/>
+          </a:prstGeom>
+          <a:solidFill>
+            <a:schemeClr val="accent1"/>
+          </a:solidFill>
+          <a:ln w="12700">
+            <a:solidFill>
+              <a:schemeClr val="accent1"/>
+            </a:solidFill>
+            <a:prstDash val="solid"/>
+          </a:ln>
+        </p:spPr>
+      </p:sp>
+      <p:sp>
+        <p:nvSpPr>
+          <p:cNvPr id="17" name="Step num 3"/>
+          <p:cNvSpPr txBox="1"/>
+          <p:nvPr/>
+        </p:nvSpPr>
+        <p:spPr>
+          <a:xfrm>
+            <a:off x="6400800" y="1417320"/>
+            <a:ext cx="594360" cy="594360"/>
+          </a:xfrm>
+          <a:prstGeom prst="rect">
+            <a:avLst/>
+          </a:prstGeom>
+          <a:noFill/>
+          <a:ln/>
+        </p:spPr>
+        <p:txBody>
+          <a:bodyPr wrap="square" lIns="0" tIns="0" rIns="0" bIns="0" rtlCol="0" anchor="ctr"/>
+          <a:lstStyle/>
+          <a:p>
+            <a:pPr algn="ctr" indent="0" marL="0">
+              <a:buNone/>
+            </a:pPr>
+            <a:r>
+              <a:rPr lang="en-US" sz="2200" b="1" dirty="0">
+                <a:solidFill>
+                  <a:schemeClr val="bg1"/>
+                </a:solidFill>
+              </a:rPr>
+              <a:t>3</a:t>
+            </a:r>
+            <a:endParaRPr lang="en-US" sz="2200" dirty="0"/>
+          </a:p>
+        </p:txBody>
+      </p:sp>
+      <p:sp>
+        <p:nvSpPr>
+          <p:cNvPr id="18" name="Step head 3"/>
+          <p:cNvSpPr txBox="1"/>
+          <p:nvPr/>
+        </p:nvSpPr>
+        <p:spPr>
+          <a:xfrm>
+            <a:off x="6400800" y="2148840"/>
+            <a:ext cx="2057400" cy="548640"/>
+          </a:xfrm>
+          <a:prstGeom prst="rect">
+            <a:avLst/>
+          </a:prstGeom>
+          <a:noFill/>
+          <a:ln/>
+        </p:spPr>
+        <p:txBody>
+          <a:bodyPr wrap="square" lIns="0" tIns="0" rIns="0" bIns="0" rtlCol="0" anchor="t"/>
+          <a:lstStyle/>
+          <a:p>
+            <a:pPr indent="0" marL="0">
+              <a:buNone/>
+            </a:pPr>
+            <a:r>
+              <a:rPr lang="en-US" sz="1400" b="1" dirty="0">
+                <a:solidFill>
+                  <a:schemeClr val="tx2"/>
+                </a:solidFill>
+              </a:rPr>
+              <a:t>並べて比べ、違いを言葉にする</a:t>
+            </a:r>
+            <a:endParaRPr lang="en-US" sz="1400" dirty="0"/>
+          </a:p>
+        </p:txBody>
+      </p:sp>
+      <p:sp>
+        <p:nvSpPr>
+          <p:cNvPr id="19" name="Step desc 3"/>
+          <p:cNvSpPr txBox="1"/>
+          <p:nvPr/>
+        </p:nvSpPr>
+        <p:spPr>
+          <a:xfrm>
+            <a:off x="6400800" y="2743200"/>
+            <a:ext cx="2057400" cy="594360"/>
+          </a:xfrm>
+          <a:prstGeom prst="rect">
+            <a:avLst/>
+          </a:prstGeom>
+          <a:noFill/>
+          <a:ln/>
+        </p:spPr>
+        <p:txBody>
+          <a:bodyPr wrap="square" lIns="0" tIns="0" rIns="0" bIns="0" rtlCol="0" anchor="t"/>
+          <a:lstStyle/>
+          <a:p>
+            <a:pPr indent="0" marL="0">
+              <a:buNone/>
+            </a:pPr>
+            <a:r>
+              <a:rPr lang="en-US" sz="1150" dirty="0">
+                <a:solidFill>
+                  <a:schemeClr val="tx1"/>
+                </a:solidFill>
+              </a:rPr>
+              <a:t>どこが変わったか、なぜ変わったかを自分の言葉で説明する</a:t>
+            </a:r>
+            <a:endParaRPr lang="en-US" sz="1150" dirty="0"/>
+          </a:p>
+        </p:txBody>
+      </p:sp>
+      <p:sp>
+        <p:nvSpPr>
+          <p:cNvPr id="20" name="Exercise info"/>
+          <p:cNvSpPr/>
+          <p:nvPr/>
+        </p:nvSpPr>
+        <p:spPr>
+          <a:xfrm>
+            <a:off x="457200" y="3611880"/>
+            <a:ext cx="8229600" cy="960120"/>
+          </a:xfrm>
+          <a:prstGeom prst="roundRect">
+            <a:avLst>
+              <a:gd name="adj" fmla="val 11429"/>
+            </a:avLst>
+          </a:prstGeom>
+          <a:solidFill>
+            <a:schemeClr val="accent5"/>
+          </a:solidFill>
+          <a:ln w="12700">
+            <a:solidFill>
+              <a:schemeClr val="accent5"/>
+            </a:solidFill>
+            <a:prstDash val="solid"/>
+          </a:ln>
+        </p:spPr>
+      </p:sp>
+      <p:sp>
+        <p:nvSpPr>
+          <p:cNvPr id="21" name="Exercise text"/>
+          <p:cNvSpPr txBox="1"/>
+          <p:nvPr/>
+        </p:nvSpPr>
+        <p:spPr>
+          <a:xfrm>
+            <a:off x="685800" y="3657600"/>
+            <a:ext cx="7772400" cy="868680"/>
+          </a:xfrm>
+          <a:prstGeom prst="rect">
+            <a:avLst/>
+          </a:prstGeom>
+          <a:noFill/>
+          <a:ln/>
+        </p:spPr>
+        <p:txBody>
+          <a:bodyPr wrap="square" lIns="0" tIns="0" rIns="0" bIns="0" rtlCol="0" anchor="ctr"/>
+          <a:lstStyle/>
+          <a:p>
+            <a:pPr indent="0" marL="0">
+              <a:spcAft>
+                <a:spcPts val="400"/>
+              </a:spcAft>
+              <a:buNone/>
+            </a:pPr>
+            <a:r>
+              <a:rPr lang="en-US" sz="1250" b="1" dirty="0">
+                <a:solidFill>
+                  <a:schemeClr val="tx2"/>
+                </a:solidFill>
+              </a:rPr>
+              <a:t>課題例　</a:t>
+            </a:r>
+            <a:pPr indent="0" marL="0">
+              <a:spcAft>
+                <a:spcPts val="400"/>
+              </a:spcAft>
+              <a:buNone/>
+            </a:pPr>
+            <a:r>
+              <a:rPr lang="en-US" sz="1250" dirty="0">
+                <a:solidFill>
+                  <a:schemeClr val="tx1"/>
+                </a:solidFill>
+              </a:rPr>
+              <a:t>「この社内文書を、全社員向けの案内メールに書き直して」</a:t>
+            </a:r>
+            <a:endParaRPr lang="en-US" sz="1250" dirty="0"/>
+          </a:p>
+          <a:p>
+            <a:pPr indent="0" marL="0">
+              <a:spcAft>
+                <a:spcPts val="400"/>
+              </a:spcAft>
+              <a:buNone/>
+            </a:pPr>
+            <a:r>
+              <a:rPr lang="en-US" sz="1250" b="1" dirty="0">
+                <a:solidFill>
+                  <a:schemeClr val="tx2"/>
+                </a:solidFill>
+              </a:rPr>
+              <a:t>所要時間　</a:t>
+            </a:r>
+            <a:pPr indent="0" marL="0">
+              <a:spcAft>
+                <a:spcPts val="400"/>
+              </a:spcAft>
+              <a:buNone/>
+            </a:pPr>
+            <a:r>
+              <a:rPr lang="en-US" sz="1250" dirty="0">
+                <a:solidFill>
+                  <a:schemeClr val="tx1"/>
+                </a:solidFill>
+              </a:rPr>
+              <a:t>15分（各5分）。終了後、隣の人と結果を見せ合う</a:t>
+            </a:r>
+            <a:endParaRPr lang="en-US" sz="1250" dirty="0"/>
+          </a:p>
+        </p:txBody>
+      </p:sp>
+      <p:sp>
+        <p:nvSpPr>
+          <p:cNvPr id="25" name="Slide Number Placeholder 0"/>
+          <p:cNvSpPr>
+            <a:spLocks noGrp="1"/>
+          </p:cNvSpPr>
+          <p:nvPr>
+            <p:ph type="sldNum" sz="quarter" idx="4294967295"/>
+          </p:nvPr>
+        </p:nvSpPr>
+        <p:spPr>
+          <a:xfrm>
+            <a:off x="8229600" y="4754880"/>
+            <a:ext cx="457200" cy="274320"/>
+          </a:xfrm>
+          <a:prstGeom prst="rect">
+            <a:avLst/>
+          </a:prstGeom>
+          <a:extLst>
+            <a:ext uri="{C572A759-6A51-4108-AA02-DFA0A04FC94B}">
+              <ma14:wrappingTextBoxFlag xmlns:ma14="http://schemas.microsoft.com/office/mac/drawingml/2011/main" val="0"/>
+            </a:ext>
+          </a:extLst>
+        </p:spPr>
+        <p:txBody>
+          <a:bodyPr/>
+          <a:lstStyle>
+            <a:lvl1pPr>
+              <a:defRPr sz="900">
+                <a:solidFill>
+                  <a:schemeClr val="accent4"/>
+                </a:solidFill>
+              </a:defRPr>
+            </a:lvl1pPr>
+          </a:lstStyle>
+          <a:p>
+            <a:pPr algn="r"/>
+            <a:fld id="{F7021451-1387-4CA6-816F-3879F97B5CBC}" type="slidenum">
+              <a:rPr b="0" lang="en-US"/>
+              <a:t>14</a:t>
+            </a:fld>
+            <a:endParaRPr lang="en-US"/>
+          </a:p>
+        </p:txBody>
+      </p:sp>
+    </p:spTree>
+  </p:cSld>
+  <p:clrMapOvr>
+    <a:masterClrMapping/>
+  </p:clrMapOvr>
+</p:sld>
+</file>
+
+<file path=ppt/slides/slide15.xml><?xml version="1.0" encoding="utf-8"?>
+<p:sld xmlns:a="http://schemas.openxmlformats.org/drawingml/2006/main" xmlns:r="http://schemas.openxmlformats.org/officeDocument/2006/relationships" xmlns:p="http://schemas.openxmlformats.org/presentationml/2006/main">
+  <p:cSld name="Slide 15">
+    <p:spTree>
+      <p:nvGrpSpPr>
+        <p:cNvPr id="1" name=""/>
+        <p:cNvGrpSpPr/>
+        <p:nvPr/>
+      </p:nvGrpSpPr>
+      <p:grpSpPr>
+        <a:xfrm>
+          <a:off x="0" y="0"/>
+          <a:ext cx="0" cy="0"/>
+          <a:chOff x="0" y="0"/>
+          <a:chExt cx="0" cy="0"/>
+        </a:xfrm>
+      </p:grpSpPr>
+      <p:sp>
+        <p:nvSpPr>
           <p:cNvPr id="2" name="Summary title"/>
           <p:cNvSpPr txBox="1"/>
           <p:nvPr/>
@@ -5466,7 +7977,7 @@
                   <a:schemeClr val="tx2"/>
                 </a:solidFill>
               </a:rPr>
-              <a:t>演習とまとめ</a:t>
+              <a:t>診断と演習</a:t>
             </a:r>
             <a:endParaRPr lang="en-US" sz="1600" dirty="0"/>
           </a:p>
@@ -5502,7 +8013,7 @@
                   <a:schemeClr val="tx1"/>
                 </a:solidFill>
               </a:rPr>
-              <a:t>同じ課題を2通りの指示で試し、明日からの行動に落とす</a:t>
+              <a:t>診断課題で今の傾向を知り、演習で練習して明日の行動に落とす</a:t>
             </a:r>
             <a:endParaRPr lang="en-US" sz="1200" dirty="0"/>
           </a:p>

</xml_diff>

<commit_message>
Rework diagnostic task for system development, no AI use required
- Handout: paper-only tasks. A = code review of a Claude-written
  rank function against a spec (three planted spec violations plus
  an unverifiable "tested" claim), B = write the first request for a
  CSV export feature, C = judge a production config change proposed
  from a generic Claude answer that conflicts with the known facts
- Answer key: solutions, corrected code, scoring checklist, bands,
  facilitation notes updated to the new tasks
- Deck: subtitle, skill descriptions, before/after example, traits,
  AI limits, diagnostic and scoring slides, exercise example and
  summary rewritten for a software development audience

Co-Authored-By: Claude Fable 5.1 <noreply@anthropic.com>
Claude-Session: https://claude.ai/code/session_01UQzmsGbHvNipHhmjBxKuyn
</commit_message>
<xml_diff>
--- a/claude-skills-lecture.pptx
+++ b/claude-skills-lecture.pptx
@@ -121,14 +121,14 @@
   <p:extLst>
     <p:ext uri="{521415D9-36F7-43E2-AB2F-B90AF26B5E84}">
       <p14:sectionLst xmlns:p14="http://schemas.microsoft.com/office/powerpoint/2010/main">
-        <p14:section name="はじめに" id="{450fa530-83c8-0831-3f57-cecba53c5495}">
+        <p14:section name="はじめに" id="{b4266081-fee5-0d39-2b1e-d477431ec36d}">
           <p14:sldIdLst>
             <p14:sldId id="256"/>
             <p14:sldId id="257"/>
             <p14:sldId id="258"/>
           </p14:sldIdLst>
         </p14:section>
-        <p14:section name="6つのスキル" id="{b46ea51a-3964-3b0b-1a55-1ba51d5ad5aa}">
+        <p14:section name="6つのスキル" id="{aa30f25c-4369-2582-157d-d94a960d2061}">
           <p14:sldIdLst>
             <p14:sldId id="259"/>
             <p14:sldId id="260"/>
@@ -136,14 +136,14 @@
             <p14:sldId id="262"/>
           </p14:sldIdLst>
         </p14:section>
-        <p14:section name="使われる人の特徴" id="{712ea7c5-db3c-0fea-f800-907c93cd6d35}">
+        <p14:section name="使われる人の特徴" id="{c9e036e7-28f7-770d-da74-11260176ab13}">
           <p14:sldIdLst>
             <p14:sldId id="263"/>
             <p14:sldId id="264"/>
             <p14:sldId id="265"/>
           </p14:sldIdLst>
         </p14:section>
-        <p14:section name="演習とまとめ" id="{33f4aae5-d101-fb34-b783-f5e8cb45d6b6}">
+        <p14:section name="演習とまとめ" id="{9b3880d9-ae35-8620-6253-9c754f1d849d}">
           <p14:sldIdLst>
             <p14:sldId id="266"/>
             <p14:sldId id="267"/>
@@ -820,7 +820,7 @@
           <a:p>
             <a:r>
               <a:rPr lang="en-US" dirty="0"/>
-              <a:t>診断課題の配布資料と講師用解答は別ファイル。課題Aの誤りは「日付の違い」「元資料と逆の内容」「存在しない数字」の3種類。参加者には「正解を当てるテストではない」と伝え、普段のやり方で取り組んでもらう。種明かしは6つのスキルの後に行うと効果が高い。</a:t>
+              <a:t>診断課題の配布資料と講師用解答は別ファイル。Claudeは使わず、紙で判断する。課題Aの仕込みは「境界値の誤り」「直近12か月が今年だけになっている」「キャンセル除外が実装されていない」の3つと、根拠のない「テスト済み」の主張。参加者には「正解を当てるテストではない」と伝え、普段のレビューと同じ感覚で取り組んでもらう。種明かしは6つのスキルの後に行うと効果が高い。</a:t>
             </a:r>
             <a:endParaRPr lang="en-US" dirty="0"/>
           </a:p>
@@ -908,7 +908,7 @@
           <a:p>
             <a:r>
               <a:rPr lang="en-US" dirty="0"/>
-              <a:t>採点は提出物3点を見れば10分程度。A3だけは本人に「Claudeに何を渡したか」を聞く。本人に返すときは×が集中した区分と、対応するスキルを一言添える。</a:t>
+              <a:t>採点は提出用紙3点を見れば1人3分程度。本人に返すときは×が集中した区分と、対応するスキルを一言添える。</a:t>
             </a:r>
             <a:endParaRPr lang="en-US" dirty="0"/>
           </a:p>
@@ -1436,7 +1436,7 @@
           <a:p>
             <a:r>
               <a:rPr lang="en-US" dirty="0"/>
-              <a:t>「新入社員に仕事を頼む」と同じ、と説明すると伝わりやすい。目的と文脈がない依頼は人間相手でも失敗する。検証は最も軽視されがちだが最も重要。</a:t>
+              <a:t>「新しく入った開発者に仕事を頼む」と同じ、と説明すると伝わりやすい。目的と文脈がない依頼は人間相手でも失敗する。検証は最も軽視されがちだが最も重要。</a:t>
             </a:r>
             <a:endParaRPr lang="en-US" dirty="0"/>
           </a:p>
@@ -1612,7 +1612,7 @@
           <a:p>
             <a:r>
               <a:rPr lang="en-US" dirty="0"/>
-              <a:t>実際に両方を講義中にデモすると効果が高い。右側の指示には「目的（役員会の事前資料）」「文脈（決定・未決）」「制約（3行以内、専門用語なし）」が入っていることを指し示す。</a:t>
+              <a:t>実際に両方を講義中にデモすると効果が高い。右側の指示には「目的（経理部の月次集計）」「文脈（/orders、100万行）」「制約（個人情報、型ヒント、既存テスト）」が入っていることを指し示す。診断課題Bと同じ題材。</a:t>
             </a:r>
             <a:endParaRPr lang="en-US" dirty="0"/>
           </a:p>
@@ -2658,7 +2658,7 @@
                   <a:schemeClr val="accent6"/>
                 </a:solidFill>
               </a:rPr>
-              <a:t>AIを使う人、AIに使われる人</a:t>
+              <a:t>システム開発編：AIを使う人、AIに使われる人</a:t>
             </a:r>
             <a:endParaRPr lang="en-US" sz="1800" dirty="0"/>
           </a:p>
@@ -2954,7 +2954,7 @@
                   <a:schemeClr val="tx1"/>
                 </a:solidFill>
               </a:rPr>
-              <a:t>学習データには締め切りがある。最新情報や社内の事情は、渡さなければ知らない</a:t>
+              <a:t>学習データには締め切りがある。ライブラリの最新版や社内の規約は、渡さなければ知らない</a:t>
             </a:r>
             <a:endParaRPr lang="en-US" sz="1100" dirty="0"/>
           </a:p>
@@ -3102,7 +3102,7 @@
                   <a:schemeClr val="tx1"/>
                 </a:solidFill>
               </a:rPr>
-              <a:t>存在しない文献や数値を自信満々に出すことがある。断定口調は正しさの証拠にならない</a:t>
+              <a:t>存在しないAPIやオプションを自信満々に出すことがある。「テスト済み」の断定も証拠にならない</a:t>
             </a:r>
             <a:endParaRPr lang="en-US" sz="1100" dirty="0"/>
           </a:p>
@@ -3214,7 +3214,7 @@
                   <a:schemeClr val="tx2"/>
                 </a:solidFill>
               </a:rPr>
-              <a:t>計算や集計が苦手</a:t>
+              <a:t>細部を間違える</a:t>
             </a:r>
             <a:endParaRPr lang="en-US" sz="1300" dirty="0"/>
           </a:p>
@@ -3250,7 +3250,7 @@
                   <a:schemeClr val="tx1"/>
                 </a:solidFill>
               </a:rPr>
-              <a:t>桁の多い計算、件数の集計、厳密な照合は間違えやすい。道具やコードで確かめる</a:t>
+              <a:t>境界値、オフバイワン、件数の集計は間違えやすい。テストと仕様の照合で確かめる</a:t>
             </a:r>
             <a:endParaRPr lang="en-US" sz="1100" dirty="0"/>
           </a:p>
@@ -3398,7 +3398,7 @@
                   <a:schemeClr val="tx1"/>
                 </a:solidFill>
               </a:rPr>
-              <a:t>組織の力関係、過去の経緯、暗黙の前提は見えていない。助言はその前提で聞く</a:t>
+              <a:t>本番のログ、過去の経緯、暗黙の前提は見えていない。助言はその前提で聞く</a:t>
             </a:r>
             <a:endParaRPr lang="en-US" sz="1100" dirty="0"/>
           </a:p>
@@ -3643,7 +3643,7 @@
                   <a:schemeClr val="tx2"/>
                 </a:solidFill>
               </a:rPr>
-              <a:t>診断課題：30分で今の傾向を知る</a:t>
+              <a:t>診断課題：Claudeを使わず、紙で判断する</a:t>
             </a:r>
             <a:endParaRPr lang="en-US" sz="2600" dirty="0"/>
           </a:p>
@@ -3755,7 +3755,7 @@
                   <a:schemeClr val="tx2"/>
                 </a:solidFill>
               </a:rPr>
-              <a:t>課題A　検証</a:t>
+              <a:t>課題A　レビュー</a:t>
             </a:r>
             <a:endParaRPr lang="en-US" sz="1300" dirty="0"/>
           </a:p>
@@ -3791,7 +3791,7 @@
                   <a:schemeClr val="tx1"/>
                 </a:solidFill>
               </a:rPr>
-              <a:t>Claudeが書いた下書きメールを、元資料をもとに送れる状態に仕上げる</a:t>
+              <a:t>Claudeが実装したコードと説明を仕様と照合し、マージ可否を判断する</a:t>
             </a:r>
             <a:endParaRPr lang="en-US" sz="1150" dirty="0"/>
           </a:p>
@@ -3838,7 +3838,7 @@
                   <a:schemeClr val="tx1"/>
                 </a:solidFill>
               </a:rPr>
-              <a:t>下書きに仕込んだ3つの誤りに気づくか。元資料と照合するか</a:t>
+              <a:t>仕込んだ3つの仕様違反に気づくか。「テスト済み」の主張を鵜呑みにしないか</a:t>
             </a:r>
             <a:endParaRPr lang="en-US" sz="1100" dirty="0"/>
           </a:p>
@@ -3950,7 +3950,7 @@
                   <a:schemeClr val="tx2"/>
                 </a:solidFill>
               </a:rPr>
-              <a:t>課題B　指示</a:t>
+              <a:t>課題B　依頼文</a:t>
             </a:r>
             <a:endParaRPr lang="en-US" sz="1300" dirty="0"/>
           </a:p>
@@ -3986,7 +3986,7 @@
                   <a:schemeClr val="tx1"/>
                 </a:solidFill>
               </a:rPr>
-              <a:t>新人向け説明資料を作るための、Claudeへの最初の依頼文を書く</a:t>
+              <a:t>CSV出力機能を実装させるための、Claudeへの最初の依頼文を書く</a:t>
             </a:r>
             <a:endParaRPr lang="en-US" sz="1150" dirty="0"/>
           </a:p>
@@ -4181,7 +4181,7 @@
                   <a:schemeClr val="tx1"/>
                 </a:solidFill>
               </a:rPr>
-              <a:t>仕上げたメールの送り先をClaudeに相談し、最終判断を書く</a:t>
+              <a:t>本番障害についてのClaudeの提案を採用するか、事実をもとに判断する</a:t>
             </a:r>
             <a:endParaRPr lang="en-US" sz="1150" dirty="0"/>
           </a:p>
@@ -4228,7 +4228,7 @@
                   <a:schemeClr val="tx1"/>
                 </a:solidFill>
               </a:rPr>
-              <a:t>資料を知らないClaudeの提案を、自分の情報で修正できるか</a:t>
+              <a:t>状況を知らないClaudeの一般論を、手元の事実で修正できるか</a:t>
             </a:r>
             <a:endParaRPr lang="en-US" sz="1100" dirty="0"/>
           </a:p>
@@ -4302,7 +4302,7 @@
                   <a:schemeClr val="tx1"/>
                 </a:solidFill>
               </a:rPr>
-              <a:t>仕上げたメール／Claudeへの依頼文／送付先の最終判断と理由</a:t>
+              <a:t>指摘とマージ可否／Claudeへの依頼文／設定変更への賛否と理由</a:t>
             </a:r>
             <a:endParaRPr lang="en-US" sz="1200" dirty="0"/>
           </a:p>
@@ -4327,7 +4327,7 @@
                   <a:schemeClr val="tx1"/>
                 </a:solidFill>
               </a:rPr>
-              <a:t>30分（A 10分、B 10分、C 5分、記入5分）。自己申告ではなく、実際の行動で見る</a:t>
+              <a:t>30分（A 12分、B 10分、C 5分、見直し3分）。資料と筆記用具のみで、普段のレビューと同じ感覚で</a:t>
             </a:r>
             <a:endParaRPr lang="en-US" sz="1200" dirty="0"/>
           </a:p>
@@ -4664,7 +4664,7 @@
                             <a:schemeClr val="tx1"/>
                           </a:solidFill>
                         </a:rPr>
-                        <a:t>仕込んだ誤りを2個以上見つけた</a:t>
+                        <a:t>仕込んだ仕様違反を2個以上指摘した</a:t>
                       </a:r>
                       <a:endParaRPr lang="en-US" sz="1100" dirty="0"/>
                     </a:p>
@@ -4782,7 +4782,7 @@
                             <a:schemeClr val="tx1"/>
                           </a:solidFill>
                         </a:rPr>
-                        <a:t>元資料と照合した形跡がある</a:t>
+                        <a:t>指摘の根拠として仕様の項目を挙げた</a:t>
                       </a:r>
                       <a:endParaRPr lang="en-US" sz="1100" dirty="0"/>
                     </a:p>
@@ -4900,7 +4900,7 @@
                             <a:schemeClr val="tx1"/>
                           </a:solidFill>
                         </a:rPr>
-                        <a:t>Claudeに頼む際、元資料を渡した</a:t>
+                        <a:t>「修正が必要」と判断した（「テスト済み」を鵜呑みにしない）</a:t>
                       </a:r>
                       <a:endParaRPr lang="en-US" sz="1100" dirty="0"/>
                     </a:p>
@@ -5136,7 +5136,7 @@
                             <a:schemeClr val="tx1"/>
                           </a:solidFill>
                         </a:rPr>
-                        <a:t>依頼文に文脈（不慣れ、Teams）がある</a:t>
+                        <a:t>依頼文に文脈（技術スタック、既存API、データ量）がある</a:t>
                       </a:r>
                       <a:endParaRPr lang="en-US" sz="1100" dirty="0"/>
                     </a:p>
@@ -5254,7 +5254,7 @@
                             <a:schemeClr val="tx1"/>
                           </a:solidFill>
                         </a:rPr>
-                        <a:t>依頼文に制約（時間、禁止事項、トーン）がある</a:t>
+                        <a:t>依頼文に制約（個人情報、規約、テスト、差分）がある</a:t>
                       </a:r>
                       <a:endParaRPr lang="en-US" sz="1100" dirty="0"/>
                     </a:p>
@@ -5372,7 +5372,7 @@
                             <a:schemeClr val="tx1"/>
                           </a:solidFill>
                         </a:rPr>
-                        <a:t>Claudeの提案と自分の判断が違う場合、理由を書けた</a:t>
+                        <a:t>本番の設定変更に反対、または保留した</a:t>
                       </a:r>
                       <a:endParaRPr lang="en-US" sz="1100" dirty="0"/>
                     </a:p>
@@ -5490,7 +5490,7 @@
                             <a:schemeClr val="tx1"/>
                           </a:solidFill>
                         </a:rPr>
-                        <a:t>送付先から役員と契約社員を除いた</a:t>
+                        <a:t>根拠として手元の事実（1ユーザーのみ、住所未登録）を挙げた</a:t>
                       </a:r>
                       <a:endParaRPr lang="en-US" sz="1100" dirty="0"/>
                     </a:p>
@@ -6582,7 +6582,7 @@
                   <a:schemeClr val="tx1"/>
                 </a:solidFill>
               </a:rPr>
-              <a:t>「この社内文書を、全社員向けの案内メールに書き直して」</a:t>
+              <a:t>「このバッチ処理に、失敗時のリトライを追加して」</a:t>
             </a:r>
             <a:endParaRPr lang="en-US" sz="1250" dirty="0"/>
           </a:p>
@@ -6985,7 +6985,7 @@
                   <a:schemeClr val="accent6"/>
                 </a:solidFill>
               </a:rPr>
-              <a:t>動かす、根拠を当たる、数を数える</a:t>
+              <a:t>動かす、テストを書く、仕様と照合する</a:t>
             </a:r>
             <a:endParaRPr lang="en-US" sz="1200" dirty="0"/>
           </a:p>
@@ -9144,7 +9144,7 @@
                   <a:schemeClr val="tx1"/>
                 </a:solidFill>
               </a:rPr>
-              <a:t>前提、制約、既存資料、やってほしくないことを最初に渡す。AIは渡されていない情報を知らない</a:t>
+              <a:t>技術スタック、既存コード、規約、やってほしくないことを最初に渡す。AIは渡されていない情報を知らない</a:t>
             </a:r>
             <a:endParaRPr lang="en-US" sz="1250" dirty="0"/>
           </a:p>
@@ -9328,7 +9328,7 @@
                   <a:schemeClr val="tx1"/>
                 </a:solidFill>
               </a:rPr>
-              <a:t>出力の正しさを自分で確かめる手段を持つ。コードなら動かす、文章なら根拠を当たる。自信ありげな間違いを見抜く唯一の方法</a:t>
+              <a:t>出力の正しさを自分で確かめる手段を持つ。動かす、テストを書く、仕様と照合する。自信ありげな間違いを見抜く唯一の方法</a:t>
             </a:r>
             <a:endParaRPr lang="en-US" sz="1250" dirty="0"/>
           </a:p>
@@ -10174,7 +10174,7 @@
         <p:spPr>
           <a:xfrm>
             <a:off x="685800" y="1920240"/>
-            <a:ext cx="3337560" cy="822960"/>
+            <a:ext cx="3337560" cy="914400"/>
           </a:xfrm>
           <a:prstGeom prst="rect">
             <a:avLst/>
@@ -10197,7 +10197,7 @@
                   <a:schemeClr val="tx1"/>
                 </a:solidFill>
               </a:rPr>
-              <a:t>「この議事録、いい感じにまとめて」</a:t>
+              <a:t>「/orders にCSV出力をつけて」</a:t>
             </a:r>
             <a:endParaRPr lang="en-US" sz="1400" dirty="0"/>
           </a:p>
@@ -10211,8 +10211,8 @@
         </p:nvSpPr>
         <p:spPr>
           <a:xfrm>
-            <a:off x="685800" y="2926080"/>
-            <a:ext cx="3337560" cy="1463040"/>
+            <a:off x="685800" y="3017520"/>
+            <a:ext cx="3337560" cy="1371600"/>
           </a:xfrm>
           <a:prstGeom prst="rect">
             <a:avLst/>
@@ -10254,7 +10254,7 @@
                   <a:schemeClr val="tx1"/>
                 </a:solidFill>
               </a:rPr>
-              <a:t>無難で薄い要約が返る</a:t>
+              <a:t>動くが、100万行を全件メモリに載せる実装が返る</a:t>
             </a:r>
             <a:endParaRPr lang="en-US" sz="1200" dirty="0"/>
           </a:p>
@@ -10272,7 +10272,7 @@
                   <a:schemeClr val="tx1"/>
                 </a:solidFill>
               </a:rPr>
-              <a:t>誰向けか、何に使うかが反映されない</a:t>
+              <a:t>氏名や住所の列もそのまま出力される</a:t>
             </a:r>
             <a:endParaRPr lang="en-US" sz="1200" dirty="0"/>
           </a:p>
@@ -10290,7 +10290,7 @@
                   <a:schemeClr val="tx1"/>
                 </a:solidFill>
               </a:rPr>
-              <a:t>どこを直せばよいか自分でも分からない</a:t>
+              <a:t>規約と合わず、レビューで差し戻しになる</a:t>
             </a:r>
             <a:endParaRPr lang="en-US" sz="1200" dirty="0"/>
           </a:p>
@@ -10392,7 +10392,7 @@
         <p:spPr>
           <a:xfrm>
             <a:off x="5120640" y="1920240"/>
-            <a:ext cx="3337560" cy="822960"/>
+            <a:ext cx="3337560" cy="914400"/>
           </a:xfrm>
           <a:prstGeom prst="rect">
             <a:avLst/>
@@ -10410,14 +10410,14 @@
               <a:buNone/>
             </a:pPr>
             <a:r>
-              <a:rPr lang="en-US" sz="1200" dirty="0">
+              <a:rPr lang="en-US" sz="1100" dirty="0">
                 <a:solidFill>
                   <a:schemeClr val="tx1"/>
                 </a:solidFill>
               </a:rPr>
-              <a:t>「来週の役員会の事前資料にする。決定事項と未決事項を分け、各3行以内。専門用語は避けて」</a:t>
-            </a:r>
-            <a:endParaRPr lang="en-US" sz="1200" dirty="0"/>
+              <a:t>「経理部の月次集計用に /orders のCSV出力を追加。100万行なのでストリーミングで。氏名・住所・電話は出力しない。型ヒント必須、既存テストは壊さない」</a:t>
+            </a:r>
+            <a:endParaRPr lang="en-US" sz="1100" dirty="0"/>
           </a:p>
         </p:txBody>
       </p:sp>
@@ -10429,8 +10429,8 @@
         </p:nvSpPr>
         <p:spPr>
           <a:xfrm>
-            <a:off x="5120640" y="2926080"/>
-            <a:ext cx="3337560" cy="1463040"/>
+            <a:off x="5120640" y="3017520"/>
+            <a:ext cx="3337560" cy="1371600"/>
           </a:xfrm>
           <a:prstGeom prst="rect">
             <a:avLst/>
@@ -10472,7 +10472,7 @@
                   <a:schemeClr val="tx1"/>
                 </a:solidFill>
               </a:rPr>
-              <a:t>ほぼそのまま使える形で返る</a:t>
+              <a:t>そのままレビューに出せる実装が返る</a:t>
             </a:r>
             <a:endParaRPr lang="en-US" sz="1200" dirty="0"/>
           </a:p>
@@ -10490,7 +10490,7 @@
                   <a:schemeClr val="tx1"/>
                 </a:solidFill>
               </a:rPr>
-              <a:t>読み手と用途に合った粒度になる</a:t>
+              <a:t>性能と個人情報の制約が最初から満たされる</a:t>
             </a:r>
             <a:endParaRPr lang="en-US" sz="1200" dirty="0"/>
           </a:p>
@@ -10865,7 +10865,7 @@
                   <a:schemeClr val="tx1"/>
                 </a:solidFill>
               </a:rPr>
-              <a:t>読まずに貼る、動かさずに提出する。責任は自分にあることを忘れている</a:t>
+              <a:t>読まずにマージする、動かさずにコミットする。責任は自分にあることを忘れている</a:t>
             </a:r>
             <a:endParaRPr lang="en-US" sz="1100" dirty="0"/>
           </a:p>
@@ -11013,7 +11013,7 @@
                   <a:schemeClr val="tx1"/>
                 </a:solidFill>
               </a:rPr>
-              <a:t>「どちらが良いですか」ばかりで、自分の基準を持たない</a:t>
+              <a:t>設計の選択を「どちらが良いですか」で決め、自分の基準を持たない</a:t>
             </a:r>
             <a:endParaRPr lang="en-US" sz="1100" dirty="0"/>
           </a:p>
@@ -11605,7 +11605,7 @@
                   <a:schemeClr val="tx1"/>
                 </a:solidFill>
               </a:rPr>
-              <a:t>知識の時点、計算の苦手さ、捏造の可能性を知らないまま使う</a:t>
+              <a:t>知識の時点、境界条件の弱さ、存在しないAPIの捏造を知らないまま使う</a:t>
             </a:r>
             <a:endParaRPr lang="en-US" sz="1100" dirty="0"/>
           </a:p>

</xml_diff>